<commit_message>
Update PowerPoint slides to display Cognitive Bias names and context without exposing A/B questions
</commit_message>
<xml_diff>
--- a/QR_Esperimenti_Bias_Domande_IT.pptx
+++ b/QR_Esperimenti_Bias_Domande_IT.pptx
@@ -3205,7 +3205,7 @@
               </a:defRPr>
             </a:pPr>
             <a:r>
-              <a:t>9. Il Problema di Linda — Fallacia della Congiunzione</a:t>
+              <a:t>9. Il Profilo di Linda (Kahneman &amp; Tversky)</a:t>
             </a:r>
           </a:p>
         </p:txBody>
@@ -3218,8 +3218,8 @@
         </p:nvSpPr>
         <p:spPr>
           <a:xfrm>
-            <a:off x="548640" y="1188720"/>
-            <a:ext cx="5303520" cy="5029200"/>
+            <a:off x="548640" y="1005840"/>
+            <a:ext cx="8229600" cy="457200"/>
           </a:xfrm>
           <a:prstGeom prst="rect">
             <a:avLst/>
@@ -3233,60 +3233,65 @@
           <a:lstStyle/>
           <a:p>
             <a:pPr>
-              <a:defRPr sz="1300">
-                <a:solidFill>
-                  <a:srgbClr val="3C3C3C"/>
-                </a:solidFill>
-              </a:defRPr>
-            </a:pPr>
-            <a:r>
-              <a:t>📌 Scenario:</a:t>
+              <a:defRPr sz="1400" b="1">
+                <a:solidFill>
+                  <a:srgbClr val="FF6584"/>
+                </a:solidFill>
+              </a:defRPr>
+            </a:pPr>
+            <a:r>
+              <a:t>🧠 Bias Cognitivo: Fallacia della Congiunzione &amp; Rappresentatività (Conjunction Fallacy)</a:t>
+            </a:r>
+          </a:p>
+        </p:txBody>
+      </p:sp>
+      <p:sp>
+        <p:nvSpPr>
+          <p:cNvPr id="4" name="TextBox 3"/>
+          <p:cNvSpPr txBox="1"/>
+          <p:nvPr/>
+        </p:nvSpPr>
+        <p:spPr>
+          <a:xfrm>
+            <a:off x="548640" y="1645920"/>
+            <a:ext cx="5120640" cy="4572000"/>
+          </a:xfrm>
+          <a:prstGeom prst="rect">
+            <a:avLst/>
+          </a:prstGeom>
+          <a:noFill/>
+        </p:spPr>
+        <p:txBody>
+          <a:bodyPr wrap="square">
+            <a:spAutoFit/>
+          </a:bodyPr>
+          <a:lstStyle/>
+          <a:p>
+            <a:pPr>
+              <a:defRPr sz="1500">
+                <a:solidFill>
+                  <a:srgbClr val="323232"/>
+                </a:solidFill>
+              </a:defRPr>
+            </a:pPr>
+            <a:r>
+              <a:t>📌 Istruzioni &amp; Contesto:</a:t>
             </a:r>
             <a:br/>
             <a:r>
-              <a:t>Linda ha 31 anni, single, brillante, laureata in filosofia, attiva contro la discriminazione e nelle manifestazioni antinucleari.</a:t>
+              <a:t>Linda ha 31 anni, è single, brillante, laureata in filosofia e da studentessa si è occupata di giustizia sociale e manifestazioni antinucleari.</a:t>
             </a:r>
             <a:br/>
-          </a:p>
-          <a:p>
-            <a:pPr>
-              <a:defRPr sz="1200" b="1">
-                <a:solidFill>
-                  <a:srgbClr val="1E5AC8"/>
-                </a:solidFill>
-              </a:defRPr>
-            </a:pPr>
-            <a:r>
-              <a:t>🅰️ Gruppo A / Group A:</a:t>
-            </a:r>
             <a:br/>
             <a:r>
-              <a:t>Qual è la probabilità (0-100%) che Linda sia una cassiera di banca?</a:t>
-            </a:r>
-            <a:br/>
-          </a:p>
-          <a:p>
-            <a:pPr>
-              <a:defRPr sz="1200" b="1">
-                <a:solidFill>
-                  <a:srgbClr val="C8325A"/>
-                </a:solidFill>
-              </a:defRPr>
-            </a:pPr>
-            <a:r>
-              <a:t>🅱️ Gruppo B / Group B:</a:t>
-            </a:r>
-            <a:br/>
-            <a:r>
-              <a:t>Qual è la probabilità (0-100%) che Linda sia una cassiera di banca e attiva nel movimento femminista?</a:t>
-            </a:r>
-            <a:br/>
+              <a:t>Inquadra il QR code per stimare la probabilità della sua occupazione attuale.</a:t>
+            </a:r>
           </a:p>
         </p:txBody>
       </p:sp>
       <p:pic>
         <p:nvPicPr>
-          <p:cNvPr id="4" name="Picture 3" descr="Problema_Linda.png"/>
+          <p:cNvPr id="5" name="Picture 4" descr="Problema_Linda.png"/>
           <p:cNvPicPr>
             <a:picLocks noChangeAspect="1"/>
           </p:cNvPicPr>
@@ -3300,8 +3305,8 @@
         </p:blipFill>
         <p:spPr>
           <a:xfrm>
-            <a:off x="6035040" y="1645920"/>
-            <a:ext cx="2743200" cy="2743200"/>
+            <a:off x="5943600" y="1645920"/>
+            <a:ext cx="2926080" cy="2926080"/>
           </a:xfrm>
           <a:prstGeom prst="rect">
             <a:avLst/>
@@ -3310,14 +3315,14 @@
       </p:pic>
       <p:sp>
         <p:nvSpPr>
-          <p:cNvPr id="5" name="TextBox 4"/>
-          <p:cNvSpPr txBox="1"/>
-          <p:nvPr/>
-        </p:nvSpPr>
-        <p:spPr>
-          <a:xfrm>
-            <a:off x="5852160" y="4663440"/>
-            <a:ext cx="3108960" cy="1097280"/>
+          <p:cNvPr id="6" name="TextBox 5"/>
+          <p:cNvSpPr txBox="1"/>
+          <p:nvPr/>
+        </p:nvSpPr>
+        <p:spPr>
+          <a:xfrm>
+            <a:off x="5760720" y="4754880"/>
+            <a:ext cx="3291840" cy="1097280"/>
           </a:xfrm>
           <a:prstGeom prst="rect">
             <a:avLst/>
@@ -3391,7 +3396,7 @@
               </a:defRPr>
             </a:pPr>
             <a:r>
-              <a:t>10. Effetto Alone — Modello Asch</a:t>
+              <a:t>10. Valutazione del Profilo Professionale</a:t>
             </a:r>
           </a:p>
         </p:txBody>
@@ -3404,8 +3409,8 @@
         </p:nvSpPr>
         <p:spPr>
           <a:xfrm>
-            <a:off x="548640" y="1188720"/>
-            <a:ext cx="5303520" cy="5029200"/>
+            <a:off x="548640" y="1005840"/>
+            <a:ext cx="8229600" cy="457200"/>
           </a:xfrm>
           <a:prstGeom prst="rect">
             <a:avLst/>
@@ -3419,68 +3424,60 @@
           <a:lstStyle/>
           <a:p>
             <a:pPr>
-              <a:defRPr sz="1300">
-                <a:solidFill>
-                  <a:srgbClr val="3C3C3C"/>
-                </a:solidFill>
-              </a:defRPr>
-            </a:pPr>
-            <a:r>
-              <a:t>📌 Scenario:</a:t>
+              <a:defRPr sz="1400" b="1">
+                <a:solidFill>
+                  <a:srgbClr val="FF6584"/>
+                </a:solidFill>
+              </a:defRPr>
+            </a:pPr>
+            <a:r>
+              <a:t>🧠 Bias Cognitivo: Effetto Alone &amp; Ordine di Presentazione (Halo Effect / Asch)</a:t>
+            </a:r>
+          </a:p>
+        </p:txBody>
+      </p:sp>
+      <p:sp>
+        <p:nvSpPr>
+          <p:cNvPr id="4" name="TextBox 3"/>
+          <p:cNvSpPr txBox="1"/>
+          <p:nvPr/>
+        </p:nvSpPr>
+        <p:spPr>
+          <a:xfrm>
+            <a:off x="548640" y="1645920"/>
+            <a:ext cx="5120640" cy="4572000"/>
+          </a:xfrm>
+          <a:prstGeom prst="rect">
+            <a:avLst/>
+          </a:prstGeom>
+          <a:noFill/>
+        </p:spPr>
+        <p:txBody>
+          <a:bodyPr wrap="square">
+            <a:spAutoFit/>
+          </a:bodyPr>
+          <a:lstStyle/>
+          <a:p>
+            <a:pPr>
+              <a:defRPr sz="1500">
+                <a:solidFill>
+                  <a:srgbClr val="323232"/>
+                </a:solidFill>
+              </a:defRPr>
+            </a:pPr>
+            <a:r>
+              <a:t>📌 Istruzioni &amp; Contesto:</a:t>
             </a:r>
             <a:br/>
             <a:r>
-              <a:t>Valutazione di un collega basata su un elenco ordinato di aggettivi.</a:t>
-            </a:r>
-            <a:br/>
-          </a:p>
-          <a:p>
-            <a:pPr>
-              <a:defRPr sz="1200" b="1">
-                <a:solidFill>
-                  <a:srgbClr val="1E5AC8"/>
-                </a:solidFill>
-              </a:defRPr>
-            </a:pPr>
-            <a:r>
-              <a:t>🅰️ Gruppo A / Group A:</a:t>
-            </a:r>
-            <a:br/>
-            <a:r>
-              <a:t>Alan: Intelligente, laborioso, impulsivo, critico, ostinato, invidioso.</a:t>
-            </a:r>
-            <a:br/>
-            <a:r>
-              <a:t>Valutazione sul lavoro (1-10).</a:t>
-            </a:r>
-            <a:br/>
-          </a:p>
-          <a:p>
-            <a:pPr>
-              <a:defRPr sz="1200" b="1">
-                <a:solidFill>
-                  <a:srgbClr val="C8325A"/>
-                </a:solidFill>
-              </a:defRPr>
-            </a:pPr>
-            <a:r>
-              <a:t>🅱️ Gruppo B / Group B:</a:t>
-            </a:r>
-            <a:br/>
-            <a:r>
-              <a:t>Ben: Invidioso, ostinato, critico, impulsivo, laborioso, intelligente.</a:t>
-            </a:r>
-            <a:br/>
-            <a:r>
-              <a:t>Valutazione sul lavoro (1-10).</a:t>
-            </a:r>
-            <a:br/>
+              <a:t>Inquadra il QR code per leggere la descrizione dei tratti di personalità del collega fornita dai suoi compagni di lavoro e valutare la tua impressione generale su di lui.</a:t>
+            </a:r>
           </a:p>
         </p:txBody>
       </p:sp>
       <p:pic>
         <p:nvPicPr>
-          <p:cNvPr id="4" name="Picture 3" descr="Effetto_Alone.png"/>
+          <p:cNvPr id="5" name="Picture 4" descr="Effetto_Alone.png"/>
           <p:cNvPicPr>
             <a:picLocks noChangeAspect="1"/>
           </p:cNvPicPr>
@@ -3494,8 +3491,8 @@
         </p:blipFill>
         <p:spPr>
           <a:xfrm>
-            <a:off x="6035040" y="1645920"/>
-            <a:ext cx="2743200" cy="2743200"/>
+            <a:off x="5943600" y="1645920"/>
+            <a:ext cx="2926080" cy="2926080"/>
           </a:xfrm>
           <a:prstGeom prst="rect">
             <a:avLst/>
@@ -3504,14 +3501,14 @@
       </p:pic>
       <p:sp>
         <p:nvSpPr>
-          <p:cNvPr id="5" name="TextBox 4"/>
-          <p:cNvSpPr txBox="1"/>
-          <p:nvPr/>
-        </p:nvSpPr>
-        <p:spPr>
-          <a:xfrm>
-            <a:off x="5852160" y="4663440"/>
-            <a:ext cx="3108960" cy="1097280"/>
+          <p:cNvPr id="6" name="TextBox 5"/>
+          <p:cNvSpPr txBox="1"/>
+          <p:nvPr/>
+        </p:nvSpPr>
+        <p:spPr>
+          <a:xfrm>
+            <a:off x="5760720" y="4754880"/>
+            <a:ext cx="3291840" cy="1097280"/>
           </a:xfrm>
           <a:prstGeom prst="rect">
             <a:avLst/>
@@ -3585,7 +3582,7 @@
               </a:defRPr>
             </a:pPr>
             <a:r>
-              <a:t>11. Effetto Dote — Tazza di Thaler</a:t>
+              <a:t>11. Il Mercato della Tazza (Thaler)</a:t>
             </a:r>
           </a:p>
         </p:txBody>
@@ -3598,8 +3595,8 @@
         </p:nvSpPr>
         <p:spPr>
           <a:xfrm>
-            <a:off x="548640" y="1188720"/>
-            <a:ext cx="5303520" cy="5029200"/>
+            <a:off x="548640" y="1005840"/>
+            <a:ext cx="8229600" cy="457200"/>
           </a:xfrm>
           <a:prstGeom prst="rect">
             <a:avLst/>
@@ -3613,68 +3610,65 @@
           <a:lstStyle/>
           <a:p>
             <a:pPr>
-              <a:defRPr sz="1300">
-                <a:solidFill>
-                  <a:srgbClr val="3C3C3C"/>
-                </a:solidFill>
-              </a:defRPr>
-            </a:pPr>
-            <a:r>
-              <a:t>📌 Scenario:</a:t>
+              <a:defRPr sz="1400" b="1">
+                <a:solidFill>
+                  <a:srgbClr val="FF6584"/>
+                </a:solidFill>
+              </a:defRPr>
+            </a:pPr>
+            <a:r>
+              <a:t>🧠 Bias Cognitivo: Effetto Dote (Endowment Effect)</a:t>
+            </a:r>
+          </a:p>
+        </p:txBody>
+      </p:sp>
+      <p:sp>
+        <p:nvSpPr>
+          <p:cNvPr id="4" name="TextBox 3"/>
+          <p:cNvSpPr txBox="1"/>
+          <p:nvPr/>
+        </p:nvSpPr>
+        <p:spPr>
+          <a:xfrm>
+            <a:off x="548640" y="1645920"/>
+            <a:ext cx="5120640" cy="4572000"/>
+          </a:xfrm>
+          <a:prstGeom prst="rect">
+            <a:avLst/>
+          </a:prstGeom>
+          <a:noFill/>
+        </p:spPr>
+        <p:txBody>
+          <a:bodyPr wrap="square">
+            <a:spAutoFit/>
+          </a:bodyPr>
+          <a:lstStyle/>
+          <a:p>
+            <a:pPr>
+              <a:defRPr sz="1500">
+                <a:solidFill>
+                  <a:srgbClr val="323232"/>
+                </a:solidFill>
+              </a:defRPr>
+            </a:pPr>
+            <a:r>
+              <a:t>📌 Istruzioni &amp; Contesto:</a:t>
             </a:r>
             <a:br/>
             <a:r>
-              <a:t>Mercato libero di compravendita di una tazza dell'istituto.</a:t>
+              <a:t>Partecipa alla simulazione di mercato per una bellissima tazza del nostro istituto.</a:t>
             </a:r>
             <a:br/>
-          </a:p>
-          <a:p>
-            <a:pPr>
-              <a:defRPr sz="1200" b="1">
-                <a:solidFill>
-                  <a:srgbClr val="1E5AC8"/>
-                </a:solidFill>
-              </a:defRPr>
-            </a:pPr>
-            <a:r>
-              <a:t>🅰️ Gruppo A / Group A:</a:t>
-            </a:r>
             <a:br/>
             <a:r>
-              <a:t>Venditori: Ti è stata regalata la tazza.</a:t>
-            </a:r>
-            <a:br/>
-            <a:r>
-              <a:t>Prezzo minimo (€) a cui la venderesti.</a:t>
-            </a:r>
-            <a:br/>
-          </a:p>
-          <a:p>
-            <a:pPr>
-              <a:defRPr sz="1200" b="1">
-                <a:solidFill>
-                  <a:srgbClr val="C8325A"/>
-                </a:solidFill>
-              </a:defRPr>
-            </a:pPr>
-            <a:r>
-              <a:t>🅱️ Gruppo B / Group B:</a:t>
-            </a:r>
-            <a:br/>
-            <a:r>
-              <a:t>Compratori: Un compagno ha ricevuto la tazza.</a:t>
-            </a:r>
-            <a:br/>
-            <a:r>
-              <a:t>Prezzo massimo (€) che pagheresti.</a:t>
-            </a:r>
-            <a:br/>
+              <a:t>Inquadra il QR code con il tuo smartphone per scoprire il tuo ruolo e indicare il tuo prezzo.</a:t>
+            </a:r>
           </a:p>
         </p:txBody>
       </p:sp>
       <p:pic>
         <p:nvPicPr>
-          <p:cNvPr id="4" name="Picture 3" descr="Effetto_Dote_Tazza.png"/>
+          <p:cNvPr id="5" name="Picture 4" descr="Effetto_Dote_Tazza.png"/>
           <p:cNvPicPr>
             <a:picLocks noChangeAspect="1"/>
           </p:cNvPicPr>
@@ -3688,8 +3682,8 @@
         </p:blipFill>
         <p:spPr>
           <a:xfrm>
-            <a:off x="6035040" y="1645920"/>
-            <a:ext cx="2743200" cy="2743200"/>
+            <a:off x="5943600" y="1645920"/>
+            <a:ext cx="2926080" cy="2926080"/>
           </a:xfrm>
           <a:prstGeom prst="rect">
             <a:avLst/>
@@ -3698,14 +3692,14 @@
       </p:pic>
       <p:sp>
         <p:nvSpPr>
-          <p:cNvPr id="5" name="TextBox 4"/>
-          <p:cNvSpPr txBox="1"/>
-          <p:nvPr/>
-        </p:nvSpPr>
-        <p:spPr>
-          <a:xfrm>
-            <a:off x="5852160" y="4663440"/>
-            <a:ext cx="3108960" cy="1097280"/>
+          <p:cNvPr id="6" name="TextBox 5"/>
+          <p:cNvSpPr txBox="1"/>
+          <p:nvPr/>
+        </p:nvSpPr>
+        <p:spPr>
+          <a:xfrm>
+            <a:off x="5760720" y="4754880"/>
+            <a:ext cx="3291840" cy="1097280"/>
           </a:xfrm>
           <a:prstGeom prst="rect">
             <a:avLst/>
@@ -3779,7 +3773,7 @@
               </a:defRPr>
             </a:pPr>
             <a:r>
-              <a:t>12. Effetto Dote — Licenza Software AI</a:t>
+              <a:t>12. Mercato della Licenza Software AI</a:t>
             </a:r>
           </a:p>
         </p:txBody>
@@ -3792,8 +3786,8 @@
         </p:nvSpPr>
         <p:spPr>
           <a:xfrm>
-            <a:off x="548640" y="1188720"/>
-            <a:ext cx="5303520" cy="5029200"/>
+            <a:off x="548640" y="1005840"/>
+            <a:ext cx="8229600" cy="457200"/>
           </a:xfrm>
           <a:prstGeom prst="rect">
             <a:avLst/>
@@ -3807,68 +3801,65 @@
           <a:lstStyle/>
           <a:p>
             <a:pPr>
-              <a:defRPr sz="1300">
-                <a:solidFill>
-                  <a:srgbClr val="3C3C3C"/>
-                </a:solidFill>
-              </a:defRPr>
-            </a:pPr>
-            <a:r>
-              <a:t>📌 Scenario:</a:t>
+              <a:defRPr sz="1400" b="1">
+                <a:solidFill>
+                  <a:srgbClr val="FF6584"/>
+                </a:solidFill>
+              </a:defRPr>
+            </a:pPr>
+            <a:r>
+              <a:t>🧠 Bias Cognitivo: Effetto Dote applicato ai Beni Digitali (Endowment Effect)</a:t>
+            </a:r>
+          </a:p>
+        </p:txBody>
+      </p:sp>
+      <p:sp>
+        <p:nvSpPr>
+          <p:cNvPr id="4" name="TextBox 3"/>
+          <p:cNvSpPr txBox="1"/>
+          <p:nvPr/>
+        </p:nvSpPr>
+        <p:spPr>
+          <a:xfrm>
+            <a:off x="548640" y="1645920"/>
+            <a:ext cx="5120640" cy="4572000"/>
+          </a:xfrm>
+          <a:prstGeom prst="rect">
+            <a:avLst/>
+          </a:prstGeom>
+          <a:noFill/>
+        </p:spPr>
+        <p:txBody>
+          <a:bodyPr wrap="square">
+            <a:spAutoFit/>
+          </a:bodyPr>
+          <a:lstStyle/>
+          <a:p>
+            <a:pPr>
+              <a:defRPr sz="1500">
+                <a:solidFill>
+                  <a:srgbClr val="323232"/>
+                </a:solidFill>
+              </a:defRPr>
+            </a:pPr>
+            <a:r>
+              <a:t>📌 Istruzioni &amp; Contesto:</a:t>
             </a:r>
             <a:br/>
             <a:r>
-              <a:t>Mercato per una Licenza Software AI diagnostica.</a:t>
+              <a:t>Partecipa alla trattativa di mercato per una rarissima licenza software diagnostica AI.</a:t>
             </a:r>
             <a:br/>
-          </a:p>
-          <a:p>
-            <a:pPr>
-              <a:defRPr sz="1200" b="1">
-                <a:solidFill>
-                  <a:srgbClr val="1E5AC8"/>
-                </a:solidFill>
-              </a:defRPr>
-            </a:pPr>
-            <a:r>
-              <a:t>🅰️ Gruppo A / Group A:</a:t>
-            </a:r>
             <a:br/>
             <a:r>
-              <a:t>Proprietario: Hai in regalo la licenza.</a:t>
-            </a:r>
-            <a:br/>
-            <a:r>
-              <a:t>Prezzo minimo (€) richiesto per cederla.</a:t>
-            </a:r>
-            <a:br/>
-          </a:p>
-          <a:p>
-            <a:pPr>
-              <a:defRPr sz="1200" b="1">
-                <a:solidFill>
-                  <a:srgbClr val="C8325A"/>
-                </a:solidFill>
-              </a:defRPr>
-            </a:pPr>
-            <a:r>
-              <a:t>🅱️ Gruppo B / Group B:</a:t>
-            </a:r>
-            <a:br/>
-            <a:r>
-              <a:t>Acquirente: Un ospedale vende la licenza.</a:t>
-            </a:r>
-            <a:br/>
-            <a:r>
-              <a:t>Prezzo massimo (€) che pagheresti.</a:t>
-            </a:r>
-            <a:br/>
+              <a:t>Inquadra il QR code per scoprire il tuo ruolo nella trattativa e la tua offerta in euro (€).</a:t>
+            </a:r>
           </a:p>
         </p:txBody>
       </p:sp>
       <p:pic>
         <p:nvPicPr>
-          <p:cNvPr id="4" name="Picture 3" descr="Effetto_Dote_AI.png"/>
+          <p:cNvPr id="5" name="Picture 4" descr="Effetto_Dote_AI.png"/>
           <p:cNvPicPr>
             <a:picLocks noChangeAspect="1"/>
           </p:cNvPicPr>
@@ -3882,8 +3873,8 @@
         </p:blipFill>
         <p:spPr>
           <a:xfrm>
-            <a:off x="6035040" y="1645920"/>
-            <a:ext cx="2743200" cy="2743200"/>
+            <a:off x="5943600" y="1645920"/>
+            <a:ext cx="2926080" cy="2926080"/>
           </a:xfrm>
           <a:prstGeom prst="rect">
             <a:avLst/>
@@ -3892,14 +3883,14 @@
       </p:pic>
       <p:sp>
         <p:nvSpPr>
-          <p:cNvPr id="5" name="TextBox 4"/>
-          <p:cNvSpPr txBox="1"/>
-          <p:nvPr/>
-        </p:nvSpPr>
-        <p:spPr>
-          <a:xfrm>
-            <a:off x="5852160" y="4663440"/>
-            <a:ext cx="3108960" cy="1097280"/>
+          <p:cNvPr id="6" name="TextBox 5"/>
+          <p:cNvSpPr txBox="1"/>
+          <p:nvPr/>
+        </p:nvSpPr>
+        <p:spPr>
+          <a:xfrm>
+            <a:off x="5760720" y="4754880"/>
+            <a:ext cx="3291840" cy="1097280"/>
           </a:xfrm>
           <a:prstGeom prst="rect">
             <a:avLst/>
@@ -3973,7 +3964,7 @@
               </a:defRPr>
             </a:pPr>
             <a:r>
-              <a:t>13. Costi Sommersi — Spettacolo a Teatro</a:t>
+              <a:t>13. Lo Spettacolo a Teatro (Kahneman)</a:t>
             </a:r>
           </a:p>
         </p:txBody>
@@ -3986,8 +3977,8 @@
         </p:nvSpPr>
         <p:spPr>
           <a:xfrm>
-            <a:off x="548640" y="1188720"/>
-            <a:ext cx="5303520" cy="5029200"/>
+            <a:off x="548640" y="1005840"/>
+            <a:ext cx="8229600" cy="457200"/>
           </a:xfrm>
           <a:prstGeom prst="rect">
             <a:avLst/>
@@ -4001,76 +3992,65 @@
           <a:lstStyle/>
           <a:p>
             <a:pPr>
-              <a:defRPr sz="1300">
-                <a:solidFill>
-                  <a:srgbClr val="3C3C3C"/>
-                </a:solidFill>
-              </a:defRPr>
-            </a:pPr>
-            <a:r>
-              <a:t>📌 Scenario:</a:t>
+              <a:defRPr sz="1400" b="1">
+                <a:solidFill>
+                  <a:srgbClr val="FF6584"/>
+                </a:solidFill>
+              </a:defRPr>
+            </a:pPr>
+            <a:r>
+              <a:t>🧠 Bias Cognitivo: Fallacia dei Costi Sommersi (Sunk Cost Fallacy)</a:t>
+            </a:r>
+          </a:p>
+        </p:txBody>
+      </p:sp>
+      <p:sp>
+        <p:nvSpPr>
+          <p:cNvPr id="4" name="TextBox 3"/>
+          <p:cNvSpPr txBox="1"/>
+          <p:nvPr/>
+        </p:nvSpPr>
+        <p:spPr>
+          <a:xfrm>
+            <a:off x="548640" y="1645920"/>
+            <a:ext cx="5120640" cy="4572000"/>
+          </a:xfrm>
+          <a:prstGeom prst="rect">
+            <a:avLst/>
+          </a:prstGeom>
+          <a:noFill/>
+        </p:spPr>
+        <p:txBody>
+          <a:bodyPr wrap="square">
+            <a:spAutoFit/>
+          </a:bodyPr>
+          <a:lstStyle/>
+          <a:p>
+            <a:pPr>
+              <a:defRPr sz="1500">
+                <a:solidFill>
+                  <a:srgbClr val="323232"/>
+                </a:solidFill>
+              </a:defRPr>
+            </a:pPr>
+            <a:r>
+              <a:t>📌 Istruzioni &amp; Contesto:</a:t>
             </a:r>
             <a:br/>
             <a:r>
-              <a:t>Tormenta di neve la sera dello spettacolo teatrale.</a:t>
+              <a:t>È la sera dello spettacolo teatrale che ti interessava molto, ma improvvisamente scoppia una tormenta di neve spaventosa.</a:t>
             </a:r>
             <a:br/>
-          </a:p>
-          <a:p>
-            <a:pPr>
-              <a:defRPr sz="1200" b="1">
-                <a:solidFill>
-                  <a:srgbClr val="1E5AC8"/>
-                </a:solidFill>
-              </a:defRPr>
-            </a:pPr>
-            <a:r>
-              <a:t>🅰️ Gruppo A / Group A:</a:t>
-            </a:r>
             <a:br/>
             <a:r>
-              <a:t>Biglietto acquistato a 50€.</a:t>
-            </a:r>
-            <a:br/>
-            <a:r>
-              <a:t>A) Vado a teatro lo stesso (sfido la tormenta)</a:t>
-            </a:r>
-            <a:br/>
-            <a:r>
-              <a:t>B) Resto a casa al caldo</a:t>
-            </a:r>
-            <a:br/>
-          </a:p>
-          <a:p>
-            <a:pPr>
-              <a:defRPr sz="1200" b="1">
-                <a:solidFill>
-                  <a:srgbClr val="C8325A"/>
-                </a:solidFill>
-              </a:defRPr>
-            </a:pPr>
-            <a:r>
-              <a:t>🅱️ Gruppo B / Group B:</a:t>
-            </a:r>
-            <a:br/>
-            <a:r>
-              <a:t>Biglietto regalato (0€).</a:t>
-            </a:r>
-            <a:br/>
-            <a:r>
-              <a:t>A) Vado a teatro lo stesso</a:t>
-            </a:r>
-            <a:br/>
-            <a:r>
-              <a:t>B) Resto a casa al caldo</a:t>
-            </a:r>
-            <a:br/>
+              <a:t>Inquadra il QR code dal tuo smartphone per indicare cosa decidi di fare.</a:t>
+            </a:r>
           </a:p>
         </p:txBody>
       </p:sp>
       <p:pic>
         <p:nvPicPr>
-          <p:cNvPr id="4" name="Picture 3" descr="Costi_Sommersi_Teatro.png"/>
+          <p:cNvPr id="5" name="Picture 4" descr="Costi_Sommersi_Teatro.png"/>
           <p:cNvPicPr>
             <a:picLocks noChangeAspect="1"/>
           </p:cNvPicPr>
@@ -4084,8 +4064,8 @@
         </p:blipFill>
         <p:spPr>
           <a:xfrm>
-            <a:off x="6035040" y="1645920"/>
-            <a:ext cx="2743200" cy="2743200"/>
+            <a:off x="5943600" y="1645920"/>
+            <a:ext cx="2926080" cy="2926080"/>
           </a:xfrm>
           <a:prstGeom prst="rect">
             <a:avLst/>
@@ -4094,14 +4074,14 @@
       </p:pic>
       <p:sp>
         <p:nvSpPr>
-          <p:cNvPr id="5" name="TextBox 4"/>
-          <p:cNvSpPr txBox="1"/>
-          <p:nvPr/>
-        </p:nvSpPr>
-        <p:spPr>
-          <a:xfrm>
-            <a:off x="5852160" y="4663440"/>
-            <a:ext cx="3108960" cy="1097280"/>
+          <p:cNvPr id="6" name="TextBox 5"/>
+          <p:cNvSpPr txBox="1"/>
+          <p:nvPr/>
+        </p:nvSpPr>
+        <p:spPr>
+          <a:xfrm>
+            <a:off x="5760720" y="4754880"/>
+            <a:ext cx="3291840" cy="1097280"/>
           </a:xfrm>
           <a:prstGeom prst="rect">
             <a:avLst/>
@@ -4175,7 +4155,7 @@
               </a:defRPr>
             </a:pPr>
             <a:r>
-              <a:t>14. Costi Sommersi — Progetto di Ricerca AI</a:t>
+              <a:t>14. Gestione Progetto di Ricerca AI</a:t>
             </a:r>
           </a:p>
         </p:txBody>
@@ -4188,8 +4168,8 @@
         </p:nvSpPr>
         <p:spPr>
           <a:xfrm>
-            <a:off x="548640" y="1188720"/>
-            <a:ext cx="5303520" cy="5029200"/>
+            <a:off x="548640" y="1005840"/>
+            <a:ext cx="8229600" cy="457200"/>
           </a:xfrm>
           <a:prstGeom prst="rect">
             <a:avLst/>
@@ -4203,76 +4183,65 @@
           <a:lstStyle/>
           <a:p>
             <a:pPr>
-              <a:defRPr sz="1300">
-                <a:solidFill>
-                  <a:srgbClr val="3C3C3C"/>
-                </a:solidFill>
-              </a:defRPr>
-            </a:pPr>
-            <a:r>
-              <a:t>📌 Scenario:</a:t>
+              <a:defRPr sz="1400" b="1">
+                <a:solidFill>
+                  <a:srgbClr val="FF6584"/>
+                </a:solidFill>
+              </a:defRPr>
+            </a:pPr>
+            <a:r>
+              <a:t>🧠 Bias Cognitivo: Costi Sommersi negli Investimenti di Sviluppo (Sunk Cost in R&amp;D)</a:t>
+            </a:r>
+          </a:p>
+        </p:txBody>
+      </p:sp>
+      <p:sp>
+        <p:nvSpPr>
+          <p:cNvPr id="4" name="TextBox 3"/>
+          <p:cNvSpPr txBox="1"/>
+          <p:nvPr/>
+        </p:nvSpPr>
+        <p:spPr>
+          <a:xfrm>
+            <a:off x="548640" y="1645920"/>
+            <a:ext cx="5120640" cy="4572000"/>
+          </a:xfrm>
+          <a:prstGeom prst="rect">
+            <a:avLst/>
+          </a:prstGeom>
+          <a:noFill/>
+        </p:spPr>
+        <p:txBody>
+          <a:bodyPr wrap="square">
+            <a:spAutoFit/>
+          </a:bodyPr>
+          <a:lstStyle/>
+          <a:p>
+            <a:pPr>
+              <a:defRPr sz="1500">
+                <a:solidFill>
+                  <a:srgbClr val="323232"/>
+                </a:solidFill>
+              </a:defRPr>
+            </a:pPr>
+            <a:r>
+              <a:t>📌 Istruzioni &amp; Contesto:</a:t>
             </a:r>
             <a:br/>
             <a:r>
-              <a:t>Google lancia un algoritmo gratuito e migliore mentre sviluppi il tuo.</a:t>
+              <a:t>Sei a capo di un team di ricerca per un nuovo algoritmo diagnostico. Durante i lavori, Google rilascia un software gratuito tecnicamente superiore.</a:t>
             </a:r>
             <a:br/>
-          </a:p>
-          <a:p>
-            <a:pPr>
-              <a:defRPr sz="1200" b="1">
-                <a:solidFill>
-                  <a:srgbClr val="1E5AC8"/>
-                </a:solidFill>
-              </a:defRPr>
-            </a:pPr>
-            <a:r>
-              <a:t>🅰️ Gruppo A / Group A:</a:t>
-            </a:r>
             <a:br/>
             <a:r>
-              <a:t>Iniziato il progetto OGGI (0 anni investiti).</a:t>
-            </a:r>
-            <a:br/>
-            <a:r>
-              <a:t>A) Continuo a sviluppare il mio</a:t>
-            </a:r>
-            <a:br/>
-            <a:r>
-              <a:t>B) Abbandono il mio progetto</a:t>
-            </a:r>
-            <a:br/>
-          </a:p>
-          <a:p>
-            <a:pPr>
-              <a:defRPr sz="1200" b="1">
-                <a:solidFill>
-                  <a:srgbClr val="C8325A"/>
-                </a:solidFill>
-              </a:defRPr>
-            </a:pPr>
-            <a:r>
-              <a:t>🅱️ Gruppo B / Group B:</a:t>
-            </a:r>
-            <a:br/>
-            <a:r>
-              <a:t>Lavori al progetto da 4 ANNI (al 90%).</a:t>
-            </a:r>
-            <a:br/>
-            <a:r>
-              <a:t>A) Continuo a sviluppare il mio</a:t>
-            </a:r>
-            <a:br/>
-            <a:r>
-              <a:t>B) Abbandono il mio progetto</a:t>
-            </a:r>
-            <a:br/>
+              <a:t>Inquadra il QR code per decidere il futuro del tuo progetto.</a:t>
+            </a:r>
           </a:p>
         </p:txBody>
       </p:sp>
       <p:pic>
         <p:nvPicPr>
-          <p:cNvPr id="4" name="Picture 3" descr="Costi_Sommersi_AI.png"/>
+          <p:cNvPr id="5" name="Picture 4" descr="Costi_Sommersi_AI.png"/>
           <p:cNvPicPr>
             <a:picLocks noChangeAspect="1"/>
           </p:cNvPicPr>
@@ -4286,8 +4255,8 @@
         </p:blipFill>
         <p:spPr>
           <a:xfrm>
-            <a:off x="6035040" y="1645920"/>
-            <a:ext cx="2743200" cy="2743200"/>
+            <a:off x="5943600" y="1645920"/>
+            <a:ext cx="2926080" cy="2926080"/>
           </a:xfrm>
           <a:prstGeom prst="rect">
             <a:avLst/>
@@ -4296,14 +4265,14 @@
       </p:pic>
       <p:sp>
         <p:nvSpPr>
-          <p:cNvPr id="5" name="TextBox 4"/>
-          <p:cNvSpPr txBox="1"/>
-          <p:nvPr/>
-        </p:nvSpPr>
-        <p:spPr>
-          <a:xfrm>
-            <a:off x="5852160" y="4663440"/>
-            <a:ext cx="3108960" cy="1097280"/>
+          <p:cNvPr id="6" name="TextBox 5"/>
+          <p:cNvSpPr txBox="1"/>
+          <p:nvPr/>
+        </p:nvSpPr>
+        <p:spPr>
+          <a:xfrm>
+            <a:off x="5760720" y="4754880"/>
+            <a:ext cx="3291840" cy="1097280"/>
           </a:xfrm>
           <a:prstGeom prst="rect">
             <a:avLst/>
@@ -4377,7 +4346,7 @@
               </a:defRPr>
             </a:pPr>
             <a:r>
-              <a:t>15. Effetto Default — Donazione Organi</a:t>
+              <a:t>15. Modulo di Assunzione Ospedaliera</a:t>
             </a:r>
           </a:p>
         </p:txBody>
@@ -4390,8 +4359,8 @@
         </p:nvSpPr>
         <p:spPr>
           <a:xfrm>
-            <a:off x="548640" y="1188720"/>
-            <a:ext cx="5303520" cy="5029200"/>
+            <a:off x="548640" y="1005840"/>
+            <a:ext cx="8229600" cy="457200"/>
           </a:xfrm>
           <a:prstGeom prst="rect">
             <a:avLst/>
@@ -4405,60 +4374,65 @@
           <a:lstStyle/>
           <a:p>
             <a:pPr>
-              <a:defRPr sz="1300">
-                <a:solidFill>
-                  <a:srgbClr val="3C3C3C"/>
-                </a:solidFill>
-              </a:defRPr>
-            </a:pPr>
-            <a:r>
-              <a:t>📌 Scenario:</a:t>
+              <a:defRPr sz="1400" b="1">
+                <a:solidFill>
+                  <a:srgbClr val="FF6584"/>
+                </a:solidFill>
+              </a:defRPr>
+            </a:pPr>
+            <a:r>
+              <a:t>🧠 Bias Cognitivo: Effetto Default &amp; Architettura delle Scelte (Default Effect / Nudge)</a:t>
+            </a:r>
+          </a:p>
+        </p:txBody>
+      </p:sp>
+      <p:sp>
+        <p:nvSpPr>
+          <p:cNvPr id="4" name="TextBox 3"/>
+          <p:cNvSpPr txBox="1"/>
+          <p:nvPr/>
+        </p:nvSpPr>
+        <p:spPr>
+          <a:xfrm>
+            <a:off x="548640" y="1645920"/>
+            <a:ext cx="5120640" cy="4572000"/>
+          </a:xfrm>
+          <a:prstGeom prst="rect">
+            <a:avLst/>
+          </a:prstGeom>
+          <a:noFill/>
+        </p:spPr>
+        <p:txBody>
+          <a:bodyPr wrap="square">
+            <a:spAutoFit/>
+          </a:bodyPr>
+          <a:lstStyle/>
+          <a:p>
+            <a:pPr>
+              <a:defRPr sz="1500">
+                <a:solidFill>
+                  <a:srgbClr val="323232"/>
+                </a:solidFill>
+              </a:defRPr>
+            </a:pPr>
+            <a:r>
+              <a:t>📌 Istruzioni &amp; Contesto:</a:t>
             </a:r>
             <a:br/>
             <a:r>
-              <a:t>Firma del nuovo modulo per dipendenti ospedalieri.</a:t>
+              <a:t>Immagina di compilare i moduli di onboarding per l'assunzione come dipendente ospedaliero.</a:t>
             </a:r>
             <a:br/>
-          </a:p>
-          <a:p>
-            <a:pPr>
-              <a:defRPr sz="1200" b="1">
-                <a:solidFill>
-                  <a:srgbClr val="1E5AC8"/>
-                </a:solidFill>
-              </a:defRPr>
-            </a:pPr>
-            <a:r>
-              <a:t>🅰️ Gruppo A / Group A:</a:t>
-            </a:r>
             <a:br/>
             <a:r>
-              <a:t>Modulo Opt-IN: [ ] Spunta se VUOI diventare donatore.</a:t>
-            </a:r>
-            <a:br/>
-          </a:p>
-          <a:p>
-            <a:pPr>
-              <a:defRPr sz="1200" b="1">
-                <a:solidFill>
-                  <a:srgbClr val="C8325A"/>
-                </a:solidFill>
-              </a:defRPr>
-            </a:pPr>
-            <a:r>
-              <a:t>🅱️ Gruppo B / Group B:</a:t>
-            </a:r>
-            <a:br/>
-            <a:r>
-              <a:t>Modulo Opt-OUT: [v] Spunta se NON VUOI diventare donatore.</a:t>
-            </a:r>
-            <a:br/>
+              <a:t>Inquadra il QR code con lo smartphone per completare la tua scelta sul modulo.</a:t>
+            </a:r>
           </a:p>
         </p:txBody>
       </p:sp>
       <p:pic>
         <p:nvPicPr>
-          <p:cNvPr id="4" name="Picture 3" descr="Effetto_Default.png"/>
+          <p:cNvPr id="5" name="Picture 4" descr="Effetto_Default.png"/>
           <p:cNvPicPr>
             <a:picLocks noChangeAspect="1"/>
           </p:cNvPicPr>
@@ -4472,8 +4446,8 @@
         </p:blipFill>
         <p:spPr>
           <a:xfrm>
-            <a:off x="6035040" y="1645920"/>
-            <a:ext cx="2743200" cy="2743200"/>
+            <a:off x="5943600" y="1645920"/>
+            <a:ext cx="2926080" cy="2926080"/>
           </a:xfrm>
           <a:prstGeom prst="rect">
             <a:avLst/>
@@ -4482,14 +4456,14 @@
       </p:pic>
       <p:sp>
         <p:nvSpPr>
-          <p:cNvPr id="5" name="TextBox 4"/>
-          <p:cNvSpPr txBox="1"/>
-          <p:nvPr/>
-        </p:nvSpPr>
-        <p:spPr>
-          <a:xfrm>
-            <a:off x="5852160" y="4663440"/>
-            <a:ext cx="3108960" cy="1097280"/>
+          <p:cNvPr id="6" name="TextBox 5"/>
+          <p:cNvSpPr txBox="1"/>
+          <p:nvPr/>
+        </p:nvSpPr>
+        <p:spPr>
+          <a:xfrm>
+            <a:off x="5760720" y="4754880"/>
+            <a:ext cx="3291840" cy="1097280"/>
           </a:xfrm>
           <a:prstGeom prst="rect">
             <a:avLst/>
@@ -4563,7 +4537,7 @@
               </a:defRPr>
             </a:pPr>
             <a:r>
-              <a:t>16. Priming Associativo — Completamento Parole</a:t>
+              <a:t>16. Test di Completamento Parole</a:t>
             </a:r>
           </a:p>
         </p:txBody>
@@ -4576,8 +4550,8 @@
         </p:nvSpPr>
         <p:spPr>
           <a:xfrm>
-            <a:off x="548640" y="1188720"/>
-            <a:ext cx="5303520" cy="5029200"/>
+            <a:off x="548640" y="1005840"/>
+            <a:ext cx="8229600" cy="457200"/>
           </a:xfrm>
           <a:prstGeom prst="rect">
             <a:avLst/>
@@ -4591,68 +4565,60 @@
           <a:lstStyle/>
           <a:p>
             <a:pPr>
-              <a:defRPr sz="1300">
-                <a:solidFill>
-                  <a:srgbClr val="3C3C3C"/>
-                </a:solidFill>
-              </a:defRPr>
-            </a:pPr>
-            <a:r>
-              <a:t>📌 Scenario:</a:t>
+              <a:defRPr sz="1400" b="1">
+                <a:solidFill>
+                  <a:srgbClr val="FF6584"/>
+                </a:solidFill>
+              </a:defRPr>
+            </a:pPr>
+            <a:r>
+              <a:t>🧠 Bias Cognitivo: Priming Semantico / Associativo (Associative Priming)</a:t>
+            </a:r>
+          </a:p>
+        </p:txBody>
+      </p:sp>
+      <p:sp>
+        <p:nvSpPr>
+          <p:cNvPr id="4" name="TextBox 3"/>
+          <p:cNvSpPr txBox="1"/>
+          <p:nvPr/>
+        </p:nvSpPr>
+        <p:spPr>
+          <a:xfrm>
+            <a:off x="548640" y="1645920"/>
+            <a:ext cx="5120640" cy="4572000"/>
+          </a:xfrm>
+          <a:prstGeom prst="rect">
+            <a:avLst/>
+          </a:prstGeom>
+          <a:noFill/>
+        </p:spPr>
+        <p:txBody>
+          <a:bodyPr wrap="square">
+            <a:spAutoFit/>
+          </a:bodyPr>
+          <a:lstStyle/>
+          <a:p>
+            <a:pPr>
+              <a:defRPr sz="1500">
+                <a:solidFill>
+                  <a:srgbClr val="323232"/>
+                </a:solidFill>
+              </a:defRPr>
+            </a:pPr>
+            <a:r>
+              <a:t>📌 Istruzioni &amp; Contesto:</a:t>
             </a:r>
             <a:br/>
             <a:r>
-              <a:t>Priming semantico sul completamento della parola S O _ P.</a:t>
-            </a:r>
-            <a:br/>
-          </a:p>
-          <a:p>
-            <a:pPr>
-              <a:defRPr sz="1200" b="1">
-                <a:solidFill>
-                  <a:srgbClr val="1E5AC8"/>
-                </a:solidFill>
-              </a:defRPr>
-            </a:pPr>
-            <a:r>
-              <a:t>🅰️ Gruppo A / Group A:</a:t>
-            </a:r>
-            <a:br/>
-            <a:r>
-              <a:t>Lettura veloce: FORCHETTA, PRANZO, FAME.</a:t>
-            </a:r>
-            <a:br/>
-            <a:r>
-              <a:t>Completa la parola: S O _ P</a:t>
-            </a:r>
-            <a:br/>
-          </a:p>
-          <a:p>
-            <a:pPr>
-              <a:defRPr sz="1200" b="1">
-                <a:solidFill>
-                  <a:srgbClr val="C8325A"/>
-                </a:solidFill>
-              </a:defRPr>
-            </a:pPr>
-            <a:r>
-              <a:t>🅱️ Gruppo B / Group B:</a:t>
-            </a:r>
-            <a:br/>
-            <a:r>
-              <a:t>Lettura veloce: DOCCIA, SCHIUMA, PULITO.</a:t>
-            </a:r>
-            <a:br/>
-            <a:r>
-              <a:t>Completa la parola: S O _ P</a:t>
-            </a:r>
-            <a:br/>
+              <a:t>Inquadra il QR code per leggere velocemente le parole che appariranno sul tuo schermo e completare la parola mancante nel minor tempo possibile.</a:t>
+            </a:r>
           </a:p>
         </p:txBody>
       </p:sp>
       <p:pic>
         <p:nvPicPr>
-          <p:cNvPr id="4" name="Picture 3" descr="Priming_Associativo.png"/>
+          <p:cNvPr id="5" name="Picture 4" descr="Priming_Associativo.png"/>
           <p:cNvPicPr>
             <a:picLocks noChangeAspect="1"/>
           </p:cNvPicPr>
@@ -4666,8 +4632,8 @@
         </p:blipFill>
         <p:spPr>
           <a:xfrm>
-            <a:off x="6035040" y="1645920"/>
-            <a:ext cx="2743200" cy="2743200"/>
+            <a:off x="5943600" y="1645920"/>
+            <a:ext cx="2926080" cy="2926080"/>
           </a:xfrm>
           <a:prstGeom prst="rect">
             <a:avLst/>
@@ -4676,14 +4642,14 @@
       </p:pic>
       <p:sp>
         <p:nvSpPr>
-          <p:cNvPr id="5" name="TextBox 4"/>
-          <p:cNvSpPr txBox="1"/>
-          <p:nvPr/>
-        </p:nvSpPr>
-        <p:spPr>
-          <a:xfrm>
-            <a:off x="5852160" y="4663440"/>
-            <a:ext cx="3108960" cy="1097280"/>
+          <p:cNvPr id="6" name="TextBox 5"/>
+          <p:cNvSpPr txBox="1"/>
+          <p:nvPr/>
+        </p:nvSpPr>
+        <p:spPr>
+          <a:xfrm>
+            <a:off x="5760720" y="4754880"/>
+            <a:ext cx="3291840" cy="1097280"/>
           </a:xfrm>
           <a:prstGeom prst="rect">
             <a:avLst/>
@@ -4757,7 +4723,7 @@
               </a:defRPr>
             </a:pPr>
             <a:r>
-              <a:t>17. Illusione di Superiorità — Dunning-Kruger</a:t>
+              <a:t>17. Valutazione delle Abilità Accademiche</a:t>
             </a:r>
           </a:p>
         </p:txBody>
@@ -4770,8 +4736,8 @@
         </p:nvSpPr>
         <p:spPr>
           <a:xfrm>
-            <a:off x="548640" y="1188720"/>
-            <a:ext cx="5303520" cy="5029200"/>
+            <a:off x="548640" y="1005840"/>
+            <a:ext cx="8229600" cy="457200"/>
           </a:xfrm>
           <a:prstGeom prst="rect">
             <a:avLst/>
@@ -4785,68 +4751,60 @@
           <a:lstStyle/>
           <a:p>
             <a:pPr>
-              <a:defRPr sz="1300">
-                <a:solidFill>
-                  <a:srgbClr val="3C3C3C"/>
-                </a:solidFill>
-              </a:defRPr>
-            </a:pPr>
-            <a:r>
-              <a:t>📌 Scenario:</a:t>
+              <a:defRPr sz="1400" b="1">
+                <a:solidFill>
+                  <a:srgbClr val="FF6584"/>
+                </a:solidFill>
+              </a:defRPr>
+            </a:pPr>
+            <a:r>
+              <a:t>🧠 Bias Cognitivo: Illusione di Superiorità &amp; Effetto Dunning-Kruger (Overconfidence)</a:t>
+            </a:r>
+          </a:p>
+        </p:txBody>
+      </p:sp>
+      <p:sp>
+        <p:nvSpPr>
+          <p:cNvPr id="4" name="TextBox 3"/>
+          <p:cNvSpPr txBox="1"/>
+          <p:nvPr/>
+        </p:nvSpPr>
+        <p:spPr>
+          <a:xfrm>
+            <a:off x="548640" y="1645920"/>
+            <a:ext cx="5120640" cy="4572000"/>
+          </a:xfrm>
+          <a:prstGeom prst="rect">
+            <a:avLst/>
+          </a:prstGeom>
+          <a:noFill/>
+        </p:spPr>
+        <p:txBody>
+          <a:bodyPr wrap="square">
+            <a:spAutoFit/>
+          </a:bodyPr>
+          <a:lstStyle/>
+          <a:p>
+            <a:pPr>
+              <a:defRPr sz="1500">
+                <a:solidFill>
+                  <a:srgbClr val="323232"/>
+                </a:solidFill>
+              </a:defRPr>
+            </a:pPr>
+            <a:r>
+              <a:t>📌 Istruzioni &amp; Contesto:</a:t>
             </a:r>
             <a:br/>
             <a:r>
-              <a:t>Autovalutazione delle proprie abilità accademiche.</a:t>
-            </a:r>
-            <a:br/>
-          </a:p>
-          <a:p>
-            <a:pPr>
-              <a:defRPr sz="1200" b="1">
-                <a:solidFill>
-                  <a:srgbClr val="1E5AC8"/>
-                </a:solidFill>
-              </a:defRPr>
-            </a:pPr>
-            <a:r>
-              <a:t>🅰️ Gruppo A / Group A:</a:t>
-            </a:r>
-            <a:br/>
-            <a:r>
-              <a:t>Ritieni la tua abilità accademica superiore alla media della classe?</a:t>
-            </a:r>
-            <a:br/>
-            <a:r>
-              <a:t>(Sopra la media / Nella media / Sotto la media)</a:t>
-            </a:r>
-            <a:br/>
-          </a:p>
-          <a:p>
-            <a:pPr>
-              <a:defRPr sz="1200" b="1">
-                <a:solidFill>
-                  <a:srgbClr val="C8325A"/>
-                </a:solidFill>
-              </a:defRPr>
-            </a:pPr>
-            <a:r>
-              <a:t>🅱️ Gruppo B / Group B:</a:t>
-            </a:r>
-            <a:br/>
-            <a:r>
-              <a:t>Ritieni la tua abilità accademica superiore a quella di Giorgio Parisi (Nobel)?</a:t>
-            </a:r>
-            <a:br/>
-            <a:r>
-              <a:t>(Sopra la sua / Nella sua / Sotto la sua)</a:t>
-            </a:r>
-            <a:br/>
+              <a:t>Inquadra il QR code con il tuo smartphone per rispondere in modo del tutto anonimo alla domanda di autovalutazione delle tue capacità accademiche.</a:t>
+            </a:r>
           </a:p>
         </p:txBody>
       </p:sp>
       <p:pic>
         <p:nvPicPr>
-          <p:cNvPr id="4" name="Picture 3" descr="Dunning_Kruger.png"/>
+          <p:cNvPr id="5" name="Picture 4" descr="Dunning_Kruger.png"/>
           <p:cNvPicPr>
             <a:picLocks noChangeAspect="1"/>
           </p:cNvPicPr>
@@ -4860,8 +4818,8 @@
         </p:blipFill>
         <p:spPr>
           <a:xfrm>
-            <a:off x="6035040" y="1645920"/>
-            <a:ext cx="2743200" cy="2743200"/>
+            <a:off x="5943600" y="1645920"/>
+            <a:ext cx="2926080" cy="2926080"/>
           </a:xfrm>
           <a:prstGeom prst="rect">
             <a:avLst/>
@@ -4870,14 +4828,14 @@
       </p:pic>
       <p:sp>
         <p:nvSpPr>
-          <p:cNvPr id="5" name="TextBox 4"/>
-          <p:cNvSpPr txBox="1"/>
-          <p:nvPr/>
-        </p:nvSpPr>
-        <p:spPr>
-          <a:xfrm>
-            <a:off x="5852160" y="4663440"/>
-            <a:ext cx="3108960" cy="1097280"/>
+          <p:cNvPr id="6" name="TextBox 5"/>
+          <p:cNvSpPr txBox="1"/>
+          <p:nvPr/>
+        </p:nvSpPr>
+        <p:spPr>
+          <a:xfrm>
+            <a:off x="5760720" y="4754880"/>
+            <a:ext cx="3291840" cy="1097280"/>
           </a:xfrm>
           <a:prstGeom prst="rect">
             <a:avLst/>
@@ -4951,7 +4909,7 @@
               </a:defRPr>
             </a:pPr>
             <a:r>
-              <a:t>18. WYSIATI — What You See Is All There Is</a:t>
+              <a:t>18. Verdetto in un Processo Penale</a:t>
             </a:r>
           </a:p>
         </p:txBody>
@@ -4964,8 +4922,8 @@
         </p:nvSpPr>
         <p:spPr>
           <a:xfrm>
-            <a:off x="548640" y="1188720"/>
-            <a:ext cx="5303520" cy="5029200"/>
+            <a:off x="548640" y="1005840"/>
+            <a:ext cx="8229600" cy="457200"/>
           </a:xfrm>
           <a:prstGeom prst="rect">
             <a:avLst/>
@@ -4979,68 +4937,60 @@
           <a:lstStyle/>
           <a:p>
             <a:pPr>
-              <a:defRPr sz="1300">
-                <a:solidFill>
-                  <a:srgbClr val="3C3C3C"/>
-                </a:solidFill>
-              </a:defRPr>
-            </a:pPr>
-            <a:r>
-              <a:t>📌 Scenario:</a:t>
+              <a:defRPr sz="1400" b="1">
+                <a:solidFill>
+                  <a:srgbClr val="FF6584"/>
+                </a:solidFill>
+              </a:defRPr>
+            </a:pPr>
+            <a:r>
+              <a:t>🧠 Bias Cognitivo: WYSIATI - What You See Is All There Is (Kahneman)</a:t>
+            </a:r>
+          </a:p>
+        </p:txBody>
+      </p:sp>
+      <p:sp>
+        <p:nvSpPr>
+          <p:cNvPr id="4" name="TextBox 3"/>
+          <p:cNvSpPr txBox="1"/>
+          <p:nvPr/>
+        </p:nvSpPr>
+        <p:spPr>
+          <a:xfrm>
+            <a:off x="548640" y="1645920"/>
+            <a:ext cx="5120640" cy="4572000"/>
+          </a:xfrm>
+          <a:prstGeom prst="rect">
+            <a:avLst/>
+          </a:prstGeom>
+          <a:noFill/>
+        </p:spPr>
+        <p:txBody>
+          <a:bodyPr wrap="square">
+            <a:spAutoFit/>
+          </a:bodyPr>
+          <a:lstStyle/>
+          <a:p>
+            <a:pPr>
+              <a:defRPr sz="1500">
+                <a:solidFill>
+                  <a:srgbClr val="323232"/>
+                </a:solidFill>
+              </a:defRPr>
+            </a:pPr>
+            <a:r>
+              <a:t>📌 Istruzioni &amp; Contesto:</a:t>
             </a:r>
             <a:br/>
             <a:r>
-              <a:t>Verdetto in un processo penale con evidenze sbilanciate.</a:t>
-            </a:r>
-            <a:br/>
-          </a:p>
-          <a:p>
-            <a:pPr>
-              <a:defRPr sz="1200" b="1">
-                <a:solidFill>
-                  <a:srgbClr val="1E5AC8"/>
-                </a:solidFill>
-              </a:defRPr>
-            </a:pPr>
-            <a:r>
-              <a:t>🅰️ Gruppo A / Group A:</a:t>
-            </a:r>
-            <a:br/>
-            <a:r>
-              <a:t>Presentata solo la testimonianza della Difesa.</a:t>
-            </a:r>
-            <a:br/>
-            <a:r>
-              <a:t>Stima colpevolezza (0-100) e sicurezza (1-10).</a:t>
-            </a:r>
-            <a:br/>
-          </a:p>
-          <a:p>
-            <a:pPr>
-              <a:defRPr sz="1200" b="1">
-                <a:solidFill>
-                  <a:srgbClr val="C8325A"/>
-                </a:solidFill>
-              </a:defRPr>
-            </a:pPr>
-            <a:r>
-              <a:t>🅱️ Gruppo B / Group B:</a:t>
-            </a:r>
-            <a:br/>
-            <a:r>
-              <a:t>Presentata solo la testimonianza del PM.</a:t>
-            </a:r>
-            <a:br/>
-            <a:r>
-              <a:t>Stima colpevolezza (0-100) e sicurezza (1-10).</a:t>
-            </a:r>
-            <a:br/>
+              <a:t>Inquadra il QR code per leggere la testimonianza presentata al processo giudiziario e indicare il tuo verdetto di colpevolezza e il tuo livello di sicurezza.</a:t>
+            </a:r>
           </a:p>
         </p:txBody>
       </p:sp>
       <p:pic>
         <p:nvPicPr>
-          <p:cNvPr id="4" name="Picture 3" descr="WYSIATI.png"/>
+          <p:cNvPr id="5" name="Picture 4" descr="WYSIATI.png"/>
           <p:cNvPicPr>
             <a:picLocks noChangeAspect="1"/>
           </p:cNvPicPr>
@@ -5054,8 +5004,8 @@
         </p:blipFill>
         <p:spPr>
           <a:xfrm>
-            <a:off x="6035040" y="1645920"/>
-            <a:ext cx="2743200" cy="2743200"/>
+            <a:off x="5943600" y="1645920"/>
+            <a:ext cx="2926080" cy="2926080"/>
           </a:xfrm>
           <a:prstGeom prst="rect">
             <a:avLst/>
@@ -5064,14 +5014,14 @@
       </p:pic>
       <p:sp>
         <p:nvSpPr>
-          <p:cNvPr id="5" name="TextBox 4"/>
-          <p:cNvSpPr txBox="1"/>
-          <p:nvPr/>
-        </p:nvSpPr>
-        <p:spPr>
-          <a:xfrm>
-            <a:off x="5852160" y="4663440"/>
-            <a:ext cx="3108960" cy="1097280"/>
+          <p:cNvPr id="6" name="TextBox 5"/>
+          <p:cNvSpPr txBox="1"/>
+          <p:nvPr/>
+        </p:nvSpPr>
+        <p:spPr>
+          <a:xfrm>
+            <a:off x="5760720" y="4754880"/>
+            <a:ext cx="3291840" cy="1097280"/>
           </a:xfrm>
           <a:prstGeom prst="rect">
             <a:avLst/>
@@ -5145,7 +5095,7 @@
               </a:defRPr>
             </a:pPr>
             <a:r>
-              <a:t>1. Loftus &amp; Palmer — Falsi Ricordi (Velocità Auto)</a:t>
+              <a:t>1. Incidente Stradale (Loftus &amp; Palmer)</a:t>
             </a:r>
           </a:p>
         </p:txBody>
@@ -5158,8 +5108,8 @@
         </p:nvSpPr>
         <p:spPr>
           <a:xfrm>
-            <a:off x="548640" y="1188720"/>
-            <a:ext cx="5303520" cy="5029200"/>
+            <a:off x="548640" y="1005840"/>
+            <a:ext cx="8229600" cy="457200"/>
           </a:xfrm>
           <a:prstGeom prst="rect">
             <a:avLst/>
@@ -5173,76 +5123,65 @@
           <a:lstStyle/>
           <a:p>
             <a:pPr>
-              <a:defRPr sz="1300">
-                <a:solidFill>
-                  <a:srgbClr val="3C3C3C"/>
-                </a:solidFill>
-              </a:defRPr>
-            </a:pPr>
-            <a:r>
-              <a:t>📌 Scenario:</a:t>
+              <a:defRPr sz="1400" b="1">
+                <a:solidFill>
+                  <a:srgbClr val="FF6584"/>
+                </a:solidFill>
+              </a:defRPr>
+            </a:pPr>
+            <a:r>
+              <a:t>🧠 Bias Cognitivo: Falsi Ricordi &amp; Suggestionabilità (False Memories)</a:t>
+            </a:r>
+          </a:p>
+        </p:txBody>
+      </p:sp>
+      <p:sp>
+        <p:nvSpPr>
+          <p:cNvPr id="4" name="TextBox 3"/>
+          <p:cNvSpPr txBox="1"/>
+          <p:nvPr/>
+        </p:nvSpPr>
+        <p:spPr>
+          <a:xfrm>
+            <a:off x="548640" y="1645920"/>
+            <a:ext cx="5120640" cy="4572000"/>
+          </a:xfrm>
+          <a:prstGeom prst="rect">
+            <a:avLst/>
+          </a:prstGeom>
+          <a:noFill/>
+        </p:spPr>
+        <p:txBody>
+          <a:bodyPr wrap="square">
+            <a:spAutoFit/>
+          </a:bodyPr>
+          <a:lstStyle/>
+          <a:p>
+            <a:pPr>
+              <a:defRPr sz="1500">
+                <a:solidFill>
+                  <a:srgbClr val="323232"/>
+                </a:solidFill>
+              </a:defRPr>
+            </a:pPr>
+            <a:r>
+              <a:t>📌 Istruzioni &amp; Contesto:</a:t>
             </a:r>
             <a:br/>
             <a:r>
-              <a:t>Hai appena visto un breve video di un incidente tra due automobili.</a:t>
+              <a:t>Guarda il breve video dell'incidente stradale mostrato a lezione.</a:t>
             </a:r>
             <a:br/>
-          </a:p>
-          <a:p>
-            <a:pPr>
-              <a:defRPr sz="1200" b="1">
-                <a:solidFill>
-                  <a:srgbClr val="1E5AC8"/>
-                </a:solidFill>
-              </a:defRPr>
-            </a:pPr>
-            <a:r>
-              <a:t>🅰️ Gruppo A / Group A:</a:t>
-            </a:r>
             <a:br/>
             <a:r>
-              <a:t>A che velocità (in km/h) andavano le auto quando si sono urtate?</a:t>
-            </a:r>
-            <a:br/>
-          </a:p>
-          <a:p>
-            <a:pPr>
-              <a:defRPr sz="1200" b="1">
-                <a:solidFill>
-                  <a:srgbClr val="C8325A"/>
-                </a:solidFill>
-              </a:defRPr>
-            </a:pPr>
-            <a:r>
-              <a:t>🅱️ Gruppo B / Group B:</a:t>
-            </a:r>
-            <a:br/>
-            <a:r>
-              <a:t>A che velocità (in km/h) andavano le auto quando si sono disintegrate?</a:t>
-            </a:r>
-            <a:br/>
-          </a:p>
-          <a:p>
-            <a:pPr>
-              <a:defRPr sz="1100" i="1">
-                <a:solidFill>
-                  <a:srgbClr val="646464"/>
-                </a:solidFill>
-              </a:defRPr>
-            </a:pPr>
-            <a:r>
-              <a:t>💡 Extra:</a:t>
-            </a:r>
-            <a:br/>
-            <a:r>
-              <a:t>Domanda comune: Hai notato dei vetri rotti a terra? (Sì / No)</a:t>
+              <a:t>Successivamente, inquadra il QR code per stimare la velocità dei veicoli e rispondere alle domande dal tuo smartphone.</a:t>
             </a:r>
           </a:p>
         </p:txBody>
       </p:sp>
       <p:pic>
         <p:nvPicPr>
-          <p:cNvPr id="4" name="Picture 3" descr="Macchina.png"/>
+          <p:cNvPr id="5" name="Picture 4" descr="Macchina.png"/>
           <p:cNvPicPr>
             <a:picLocks noChangeAspect="1"/>
           </p:cNvPicPr>
@@ -5256,8 +5195,8 @@
         </p:blipFill>
         <p:spPr>
           <a:xfrm>
-            <a:off x="6035040" y="1645920"/>
-            <a:ext cx="2743200" cy="2743200"/>
+            <a:off x="5943600" y="1645920"/>
+            <a:ext cx="2926080" cy="2926080"/>
           </a:xfrm>
           <a:prstGeom prst="rect">
             <a:avLst/>
@@ -5266,14 +5205,14 @@
       </p:pic>
       <p:sp>
         <p:nvSpPr>
-          <p:cNvPr id="5" name="TextBox 4"/>
-          <p:cNvSpPr txBox="1"/>
-          <p:nvPr/>
-        </p:nvSpPr>
-        <p:spPr>
-          <a:xfrm>
-            <a:off x="5852160" y="4663440"/>
-            <a:ext cx="3108960" cy="1097280"/>
+          <p:cNvPr id="6" name="TextBox 5"/>
+          <p:cNvSpPr txBox="1"/>
+          <p:nvPr/>
+        </p:nvSpPr>
+        <p:spPr>
+          <a:xfrm>
+            <a:off x="5760720" y="4754880"/>
+            <a:ext cx="3291840" cy="1097280"/>
           </a:xfrm>
           <a:prstGeom prst="rect">
             <a:avLst/>
@@ -5347,7 +5286,7 @@
               </a:defRPr>
             </a:pPr>
             <a:r>
-              <a:t>19. Illusione di Focalizzazione — Felicità</a:t>
+              <a:t>19. Sondaggio sul Benessere Personale</a:t>
             </a:r>
           </a:p>
         </p:txBody>
@@ -5360,8 +5299,8 @@
         </p:nvSpPr>
         <p:spPr>
           <a:xfrm>
-            <a:off x="548640" y="1188720"/>
-            <a:ext cx="5303520" cy="5029200"/>
+            <a:off x="548640" y="1005840"/>
+            <a:ext cx="8229600" cy="457200"/>
           </a:xfrm>
           <a:prstGeom prst="rect">
             <a:avLst/>
@@ -5375,68 +5314,60 @@
           <a:lstStyle/>
           <a:p>
             <a:pPr>
-              <a:defRPr sz="1300">
-                <a:solidFill>
-                  <a:srgbClr val="3C3C3C"/>
-                </a:solidFill>
-              </a:defRPr>
-            </a:pPr>
-            <a:r>
-              <a:t>📌 Scenario:</a:t>
+              <a:defRPr sz="1400" b="1">
+                <a:solidFill>
+                  <a:srgbClr val="FF6584"/>
+                </a:solidFill>
+              </a:defRPr>
+            </a:pPr>
+            <a:r>
+              <a:t>🧠 Bias Cognitivo: Illusione di Focalizzazione (Focusing Illusion)</a:t>
+            </a:r>
+          </a:p>
+        </p:txBody>
+      </p:sp>
+      <p:sp>
+        <p:nvSpPr>
+          <p:cNvPr id="4" name="TextBox 3"/>
+          <p:cNvSpPr txBox="1"/>
+          <p:nvPr/>
+        </p:nvSpPr>
+        <p:spPr>
+          <a:xfrm>
+            <a:off x="548640" y="1645920"/>
+            <a:ext cx="5120640" cy="4572000"/>
+          </a:xfrm>
+          <a:prstGeom prst="rect">
+            <a:avLst/>
+          </a:prstGeom>
+          <a:noFill/>
+        </p:spPr>
+        <p:txBody>
+          <a:bodyPr wrap="square">
+            <a:spAutoFit/>
+          </a:bodyPr>
+          <a:lstStyle/>
+          <a:p>
+            <a:pPr>
+              <a:defRPr sz="1500">
+                <a:solidFill>
+                  <a:srgbClr val="323232"/>
+                </a:solidFill>
+              </a:defRPr>
+            </a:pPr>
+            <a:r>
+              <a:t>📌 Istruzioni &amp; Contesto:</a:t>
             </a:r>
             <a:br/>
             <a:r>
-              <a:t>Ordine delle domande sul benessere e vita sentimentale.</a:t>
-            </a:r>
-            <a:br/>
-          </a:p>
-          <a:p>
-            <a:pPr>
-              <a:defRPr sz="1200" b="1">
-                <a:solidFill>
-                  <a:srgbClr val="1E5AC8"/>
-                </a:solidFill>
-              </a:defRPr>
-            </a:pPr>
-            <a:r>
-              <a:t>🅰️ Gruppo A / Group A:</a:t>
-            </a:r>
-            <a:br/>
-            <a:r>
-              <a:t>1. Quanto sei felice (1-10)?</a:t>
-            </a:r>
-            <a:br/>
-            <a:r>
-              <a:t>2. Quante uscite romantiche nell'ultimo mese?</a:t>
-            </a:r>
-            <a:br/>
-          </a:p>
-          <a:p>
-            <a:pPr>
-              <a:defRPr sz="1200" b="1">
-                <a:solidFill>
-                  <a:srgbClr val="C8325A"/>
-                </a:solidFill>
-              </a:defRPr>
-            </a:pPr>
-            <a:r>
-              <a:t>🅱️ Gruppo B / Group B:</a:t>
-            </a:r>
-            <a:br/>
-            <a:r>
-              <a:t>1. Quante uscite romantiche nell'ultimo mese?</a:t>
-            </a:r>
-            <a:br/>
-            <a:r>
-              <a:t>2. Quanto sei felice (1-10)?</a:t>
-            </a:r>
-            <a:br/>
+              <a:t>Inquadra il QR code per rispondere a un breve sondaggio sul tuo benessere generale e sulla tua soddisfazione di vita.</a:t>
+            </a:r>
           </a:p>
         </p:txBody>
       </p:sp>
       <p:pic>
         <p:nvPicPr>
-          <p:cNvPr id="4" name="Picture 3" descr="Illusione_Focalizzazione.png"/>
+          <p:cNvPr id="5" name="Picture 4" descr="Illusione_Focalizzazione.png"/>
           <p:cNvPicPr>
             <a:picLocks noChangeAspect="1"/>
           </p:cNvPicPr>
@@ -5450,8 +5381,8 @@
         </p:blipFill>
         <p:spPr>
           <a:xfrm>
-            <a:off x="6035040" y="1645920"/>
-            <a:ext cx="2743200" cy="2743200"/>
+            <a:off x="5943600" y="1645920"/>
+            <a:ext cx="2926080" cy="2926080"/>
           </a:xfrm>
           <a:prstGeom prst="rect">
             <a:avLst/>
@@ -5460,14 +5391,14 @@
       </p:pic>
       <p:sp>
         <p:nvSpPr>
-          <p:cNvPr id="5" name="TextBox 4"/>
-          <p:cNvSpPr txBox="1"/>
-          <p:nvPr/>
-        </p:nvSpPr>
-        <p:spPr>
-          <a:xfrm>
-            <a:off x="5852160" y="4663440"/>
-            <a:ext cx="3108960" cy="1097280"/>
+          <p:cNvPr id="6" name="TextBox 5"/>
+          <p:cNvSpPr txBox="1"/>
+          <p:nvPr/>
+        </p:nvSpPr>
+        <p:spPr>
+          <a:xfrm>
+            <a:off x="5760720" y="4754880"/>
+            <a:ext cx="3291840" cy="1097280"/>
           </a:xfrm>
           <a:prstGeom prst="rect">
             <a:avLst/>
@@ -5541,7 +5472,7 @@
               </a:defRPr>
             </a:pPr>
             <a:r>
-              <a:t>20. Base Rate Neglect — Paradosso Diagnostico</a:t>
+              <a:t>20. Il Paradosso Diagnostico</a:t>
             </a:r>
           </a:p>
         </p:txBody>
@@ -5554,8 +5485,8 @@
         </p:nvSpPr>
         <p:spPr>
           <a:xfrm>
-            <a:off x="548640" y="1188720"/>
-            <a:ext cx="5303520" cy="5029200"/>
+            <a:off x="548640" y="1005840"/>
+            <a:ext cx="8229600" cy="457200"/>
           </a:xfrm>
           <a:prstGeom prst="rect">
             <a:avLst/>
@@ -5569,47 +5500,65 @@
           <a:lstStyle/>
           <a:p>
             <a:pPr>
-              <a:defRPr sz="1300">
-                <a:solidFill>
-                  <a:srgbClr val="3C3C3C"/>
-                </a:solidFill>
-              </a:defRPr>
-            </a:pPr>
-            <a:r>
-              <a:t>📌 Scenario:</a:t>
+              <a:defRPr sz="1400" b="1">
+                <a:solidFill>
+                  <a:srgbClr val="FF6584"/>
+                </a:solidFill>
+              </a:defRPr>
+            </a:pPr>
+            <a:r>
+              <a:t>🧠 Bias Cognitivo: Disattenzione per la Frequenza di Base (Base Rate Neglect)</a:t>
+            </a:r>
+          </a:p>
+        </p:txBody>
+      </p:sp>
+      <p:sp>
+        <p:nvSpPr>
+          <p:cNvPr id="4" name="TextBox 3"/>
+          <p:cNvSpPr txBox="1"/>
+          <p:nvPr/>
+        </p:nvSpPr>
+        <p:spPr>
+          <a:xfrm>
+            <a:off x="548640" y="1645920"/>
+            <a:ext cx="5120640" cy="4572000"/>
+          </a:xfrm>
+          <a:prstGeom prst="rect">
+            <a:avLst/>
+          </a:prstGeom>
+          <a:noFill/>
+        </p:spPr>
+        <p:txBody>
+          <a:bodyPr wrap="square">
+            <a:spAutoFit/>
+          </a:bodyPr>
+          <a:lstStyle/>
+          <a:p>
+            <a:pPr>
+              <a:defRPr sz="1500">
+                <a:solidFill>
+                  <a:srgbClr val="323232"/>
+                </a:solidFill>
+              </a:defRPr>
+            </a:pPr>
+            <a:r>
+              <a:t>📌 Istruzioni &amp; Contesto:</a:t>
             </a:r>
             <a:br/>
             <a:r>
-              <a:t>Malattia rara al 1% della popolazione. Test preciso al 95%. Risulti POSITIVO.</a:t>
+              <a:t>Una malattia rara colpisce l'1% della popolazione mondiale. Un test in grado di rilevarla è accurato al 95%. Risulti POSITIVO.</a:t>
             </a:r>
             <a:br/>
-          </a:p>
-          <a:p>
-            <a:pPr>
-              <a:defRPr sz="1300" b="1">
-                <a:solidFill>
-                  <a:srgbClr val="1E965A"/>
-                </a:solidFill>
-              </a:defRPr>
-            </a:pPr>
-            <a:r>
-              <a:t>❓ Domanda / Question:</a:t>
-            </a:r>
             <a:br/>
             <a:r>
-              <a:t>Qual è la probabilità effettiva (0-100%) che tu sia realmente malato?</a:t>
-            </a:r>
-            <a:br/>
-            <a:r>
-              <a:t>(Risposta statistica corretta: ~16%)</a:t>
-            </a:r>
-            <a:br/>
+              <a:t>Inquadra il QR code per stimare la reale probabilità di avere la malattia.</a:t>
+            </a:r>
           </a:p>
         </p:txBody>
       </p:sp>
       <p:pic>
         <p:nvPicPr>
-          <p:cNvPr id="4" name="Picture 3" descr="Base_Rate_Neglect.png"/>
+          <p:cNvPr id="5" name="Picture 4" descr="Base_Rate_Neglect.png"/>
           <p:cNvPicPr>
             <a:picLocks noChangeAspect="1"/>
           </p:cNvPicPr>
@@ -5623,8 +5572,8 @@
         </p:blipFill>
         <p:spPr>
           <a:xfrm>
-            <a:off x="6035040" y="1645920"/>
-            <a:ext cx="2743200" cy="2743200"/>
+            <a:off x="5943600" y="1645920"/>
+            <a:ext cx="2926080" cy="2926080"/>
           </a:xfrm>
           <a:prstGeom prst="rect">
             <a:avLst/>
@@ -5633,14 +5582,14 @@
       </p:pic>
       <p:sp>
         <p:nvSpPr>
-          <p:cNvPr id="5" name="TextBox 4"/>
-          <p:cNvSpPr txBox="1"/>
-          <p:nvPr/>
-        </p:nvSpPr>
-        <p:spPr>
-          <a:xfrm>
-            <a:off x="5852160" y="4663440"/>
-            <a:ext cx="3108960" cy="1097280"/>
+          <p:cNvPr id="6" name="TextBox 5"/>
+          <p:cNvSpPr txBox="1"/>
+          <p:nvPr/>
+        </p:nvSpPr>
+        <p:spPr>
+          <a:xfrm>
+            <a:off x="5760720" y="4754880"/>
+            <a:ext cx="3291840" cy="1097280"/>
           </a:xfrm>
           <a:prstGeom prst="rect">
             <a:avLst/>
@@ -5714,7 +5663,7 @@
               </a:defRPr>
             </a:pPr>
             <a:r>
-              <a:t>21. Decoy Effect — L'Esca (The Economist)</a:t>
+              <a:t>21. Scelta dell'Abbonamento (The Economist)</a:t>
             </a:r>
           </a:p>
         </p:txBody>
@@ -5727,8 +5676,8 @@
         </p:nvSpPr>
         <p:spPr>
           <a:xfrm>
-            <a:off x="548640" y="1188720"/>
-            <a:ext cx="5303520" cy="5029200"/>
+            <a:off x="548640" y="1005840"/>
+            <a:ext cx="8229600" cy="457200"/>
           </a:xfrm>
           <a:prstGeom prst="rect">
             <a:avLst/>
@@ -5742,51 +5691,65 @@
           <a:lstStyle/>
           <a:p>
             <a:pPr>
-              <a:defRPr sz="1300">
-                <a:solidFill>
-                  <a:srgbClr val="3C3C3C"/>
-                </a:solidFill>
-              </a:defRPr>
-            </a:pPr>
-            <a:r>
-              <a:t>📌 Scenario:</a:t>
+              <a:defRPr sz="1400" b="1">
+                <a:solidFill>
+                  <a:srgbClr val="FF6584"/>
+                </a:solidFill>
+              </a:defRPr>
+            </a:pPr>
+            <a:r>
+              <a:t>🧠 Bias Cognitivo: Effetto Esca / Attrazione (Decoy Effect)</a:t>
+            </a:r>
+          </a:p>
+        </p:txBody>
+      </p:sp>
+      <p:sp>
+        <p:nvSpPr>
+          <p:cNvPr id="4" name="TextBox 3"/>
+          <p:cNvSpPr txBox="1"/>
+          <p:nvPr/>
+        </p:nvSpPr>
+        <p:spPr>
+          <a:xfrm>
+            <a:off x="548640" y="1645920"/>
+            <a:ext cx="5120640" cy="4572000"/>
+          </a:xfrm>
+          <a:prstGeom prst="rect">
+            <a:avLst/>
+          </a:prstGeom>
+          <a:noFill/>
+        </p:spPr>
+        <p:txBody>
+          <a:bodyPr wrap="square">
+            <a:spAutoFit/>
+          </a:bodyPr>
+          <a:lstStyle/>
+          <a:p>
+            <a:pPr>
+              <a:defRPr sz="1500">
+                <a:solidFill>
+                  <a:srgbClr val="323232"/>
+                </a:solidFill>
+              </a:defRPr>
+            </a:pPr>
+            <a:r>
+              <a:t>📌 Istruzioni &amp; Contesto:</a:t>
             </a:r>
             <a:br/>
             <a:r>
-              <a:t>Scegli un abbonamento alla rivista The Economist:</a:t>
+              <a:t>Devi scegliere la formula d'abbonamento alla rivista The Economist che ritieni più conveniente.</a:t>
             </a:r>
             <a:br/>
-          </a:p>
-          <a:p>
-            <a:pPr>
-              <a:defRPr sz="1300" b="1">
-                <a:solidFill>
-                  <a:srgbClr val="1E965A"/>
-                </a:solidFill>
-              </a:defRPr>
-            </a:pPr>
-            <a:r>
-              <a:t>❓ Domanda / Question:</a:t>
-            </a:r>
             <a:br/>
             <a:r>
-              <a:t>A) Solo Web (50€)</a:t>
-            </a:r>
-            <a:br/>
-            <a:r>
-              <a:t>B) Solo Cartaceo (120€ - Opzione Esca)</a:t>
-            </a:r>
-            <a:br/>
-            <a:r>
-              <a:t>C) Web + Cartaceo (120€)</a:t>
-            </a:r>
-            <a:br/>
+              <a:t>Inquadra il QR code con lo smartphone per selezionare la tua scelta.</a:t>
+            </a:r>
           </a:p>
         </p:txBody>
       </p:sp>
       <p:pic>
         <p:nvPicPr>
-          <p:cNvPr id="4" name="Picture 3" descr="L_Esca.png"/>
+          <p:cNvPr id="5" name="Picture 4" descr="L_Esca.png"/>
           <p:cNvPicPr>
             <a:picLocks noChangeAspect="1"/>
           </p:cNvPicPr>
@@ -5800,8 +5763,8 @@
         </p:blipFill>
         <p:spPr>
           <a:xfrm>
-            <a:off x="6035040" y="1645920"/>
-            <a:ext cx="2743200" cy="2743200"/>
+            <a:off x="5943600" y="1645920"/>
+            <a:ext cx="2926080" cy="2926080"/>
           </a:xfrm>
           <a:prstGeom prst="rect">
             <a:avLst/>
@@ -5810,14 +5773,14 @@
       </p:pic>
       <p:sp>
         <p:nvSpPr>
-          <p:cNvPr id="5" name="TextBox 4"/>
-          <p:cNvSpPr txBox="1"/>
-          <p:nvPr/>
-        </p:nvSpPr>
-        <p:spPr>
-          <a:xfrm>
-            <a:off x="5852160" y="4663440"/>
-            <a:ext cx="3108960" cy="1097280"/>
+          <p:cNvPr id="6" name="TextBox 5"/>
+          <p:cNvSpPr txBox="1"/>
+          <p:nvPr/>
+        </p:nvSpPr>
+        <p:spPr>
+          <a:xfrm>
+            <a:off x="5760720" y="4754880"/>
+            <a:ext cx="3291840" cy="1097280"/>
           </a:xfrm>
           <a:prstGeom prst="rect">
             <a:avLst/>
@@ -5891,7 +5854,7 @@
               </a:defRPr>
             </a:pPr>
             <a:r>
-              <a:t>22. Regressione alla Media — Lode vs Castigo</a:t>
+              <a:t>22. L'Effetto dell'Istruzione di Volo</a:t>
             </a:r>
           </a:p>
         </p:txBody>
@@ -5904,8 +5867,8 @@
         </p:nvSpPr>
         <p:spPr>
           <a:xfrm>
-            <a:off x="548640" y="1188720"/>
-            <a:ext cx="5303520" cy="5029200"/>
+            <a:off x="548640" y="1005840"/>
+            <a:ext cx="8229600" cy="457200"/>
           </a:xfrm>
           <a:prstGeom prst="rect">
             <a:avLst/>
@@ -5919,47 +5882,65 @@
           <a:lstStyle/>
           <a:p>
             <a:pPr>
-              <a:defRPr sz="1300">
-                <a:solidFill>
-                  <a:srgbClr val="3C3C3C"/>
-                </a:solidFill>
-              </a:defRPr>
-            </a:pPr>
-            <a:r>
-              <a:t>📌 Scenario:</a:t>
+              <a:defRPr sz="1400" b="1">
+                <a:solidFill>
+                  <a:srgbClr val="FF6584"/>
+                </a:solidFill>
+              </a:defRPr>
+            </a:pPr>
+            <a:r>
+              <a:t>🧠 Bias Cognitivo: Illusioni Causali vs Regressione alla Media (Regression to the Mean)</a:t>
+            </a:r>
+          </a:p>
+        </p:txBody>
+      </p:sp>
+      <p:sp>
+        <p:nvSpPr>
+          <p:cNvPr id="4" name="TextBox 3"/>
+          <p:cNvSpPr txBox="1"/>
+          <p:nvPr/>
+        </p:nvSpPr>
+        <p:spPr>
+          <a:xfrm>
+            <a:off x="548640" y="1645920"/>
+            <a:ext cx="5120640" cy="4572000"/>
+          </a:xfrm>
+          <a:prstGeom prst="rect">
+            <a:avLst/>
+          </a:prstGeom>
+          <a:noFill/>
+        </p:spPr>
+        <p:txBody>
+          <a:bodyPr wrap="square">
+            <a:spAutoFit/>
+          </a:bodyPr>
+          <a:lstStyle/>
+          <a:p>
+            <a:pPr>
+              <a:defRPr sz="1500">
+                <a:solidFill>
+                  <a:srgbClr val="323232"/>
+                </a:solidFill>
+              </a:defRPr>
+            </a:pPr>
+            <a:r>
+              <a:t>📌 Istruzioni &amp; Contesto:</a:t>
             </a:r>
             <a:br/>
             <a:r>
-              <a:t>Istruttori di volo: sgridare migliora l'atterraggio successivo, lodare lo peggiora.</a:t>
+              <a:t>Gli istruttori di volo israeliani notano che sgridare dopo un errore migliora la manovra successiva, mentre lodare la peggiora.</a:t>
             </a:r>
             <a:br/>
-          </a:p>
-          <a:p>
-            <a:pPr>
-              <a:defRPr sz="1300" b="1">
-                <a:solidFill>
-                  <a:srgbClr val="1E965A"/>
-                </a:solidFill>
-              </a:defRPr>
-            </a:pPr>
-            <a:r>
-              <a:t>❓ Domanda / Question:</a:t>
-            </a:r>
             <a:br/>
             <a:r>
-              <a:t>A) Intuizione psicologica (la lode vizia, il castigo funziona)</a:t>
-            </a:r>
-            <a:br/>
-            <a:r>
-              <a:t>B) Errore statistico (regressione alla media)</a:t>
-            </a:r>
-            <a:br/>
+              <a:t>Inquadra il QR code per spiegare perché si verifica questo fenomeno.</a:t>
+            </a:r>
           </a:p>
         </p:txBody>
       </p:sp>
       <p:pic>
         <p:nvPicPr>
-          <p:cNvPr id="4" name="Picture 3" descr="Regressione_Media.png"/>
+          <p:cNvPr id="5" name="Picture 4" descr="Regressione_Media.png"/>
           <p:cNvPicPr>
             <a:picLocks noChangeAspect="1"/>
           </p:cNvPicPr>
@@ -5973,8 +5954,8 @@
         </p:blipFill>
         <p:spPr>
           <a:xfrm>
-            <a:off x="6035040" y="1645920"/>
-            <a:ext cx="2743200" cy="2743200"/>
+            <a:off x="5943600" y="1645920"/>
+            <a:ext cx="2926080" cy="2926080"/>
           </a:xfrm>
           <a:prstGeom prst="rect">
             <a:avLst/>
@@ -5983,14 +5964,14 @@
       </p:pic>
       <p:sp>
         <p:nvSpPr>
-          <p:cNvPr id="5" name="TextBox 4"/>
-          <p:cNvSpPr txBox="1"/>
-          <p:nvPr/>
-        </p:nvSpPr>
-        <p:spPr>
-          <a:xfrm>
-            <a:off x="5852160" y="4663440"/>
-            <a:ext cx="3108960" cy="1097280"/>
+          <p:cNvPr id="6" name="TextBox 5"/>
+          <p:cNvSpPr txBox="1"/>
+          <p:nvPr/>
+        </p:nvSpPr>
+        <p:spPr>
+          <a:xfrm>
+            <a:off x="5760720" y="4754880"/>
+            <a:ext cx="3291840" cy="1097280"/>
           </a:xfrm>
           <a:prstGeom prst="rect">
             <a:avLst/>
@@ -6064,7 +6045,7 @@
               </a:defRPr>
             </a:pPr>
             <a:r>
-              <a:t>2. Asian Disease Problem — Framing Effect</a:t>
+              <a:t>2. Il Paradosso della Malattia Asiatica</a:t>
             </a:r>
           </a:p>
         </p:txBody>
@@ -6077,8 +6058,8 @@
         </p:nvSpPr>
         <p:spPr>
           <a:xfrm>
-            <a:off x="548640" y="1188720"/>
-            <a:ext cx="5303520" cy="5029200"/>
+            <a:off x="548640" y="1005840"/>
+            <a:ext cx="8229600" cy="457200"/>
           </a:xfrm>
           <a:prstGeom prst="rect">
             <a:avLst/>
@@ -6092,68 +6073,65 @@
           <a:lstStyle/>
           <a:p>
             <a:pPr>
-              <a:defRPr sz="1300">
-                <a:solidFill>
-                  <a:srgbClr val="3C3C3C"/>
-                </a:solidFill>
-              </a:defRPr>
-            </a:pPr>
-            <a:r>
-              <a:t>📌 Scenario:</a:t>
+              <a:defRPr sz="1400" b="1">
+                <a:solidFill>
+                  <a:srgbClr val="FF6584"/>
+                </a:solidFill>
+              </a:defRPr>
+            </a:pPr>
+            <a:r>
+              <a:t>🧠 Bias Cognitivo: Effetto Framing / Formulazione della Scelta (Framing Effect)</a:t>
+            </a:r>
+          </a:p>
+        </p:txBody>
+      </p:sp>
+      <p:sp>
+        <p:nvSpPr>
+          <p:cNvPr id="4" name="TextBox 3"/>
+          <p:cNvSpPr txBox="1"/>
+          <p:nvPr/>
+        </p:nvSpPr>
+        <p:spPr>
+          <a:xfrm>
+            <a:off x="548640" y="1645920"/>
+            <a:ext cx="5120640" cy="4572000"/>
+          </a:xfrm>
+          <a:prstGeom prst="rect">
+            <a:avLst/>
+          </a:prstGeom>
+          <a:noFill/>
+        </p:spPr>
+        <p:txBody>
+          <a:bodyPr wrap="square">
+            <a:spAutoFit/>
+          </a:bodyPr>
+          <a:lstStyle/>
+          <a:p>
+            <a:pPr>
+              <a:defRPr sz="1500">
+                <a:solidFill>
+                  <a:srgbClr val="323232"/>
+                </a:solidFill>
+              </a:defRPr>
+            </a:pPr>
+            <a:r>
+              <a:t>📌 Istruzioni &amp; Contesto:</a:t>
             </a:r>
             <a:br/>
             <a:r>
-              <a:t>Un'epidemia asiatica minaccia 600 persone. Due programmi possibili:</a:t>
+              <a:t>Un'epidemia asiatica molto contagiosa rischia di colpire 600 persone. Sono stati proposti due diversi programmi sanitari d'intervento per affrontarla.</a:t>
             </a:r>
             <a:br/>
-          </a:p>
-          <a:p>
-            <a:pPr>
-              <a:defRPr sz="1200" b="1">
-                <a:solidFill>
-                  <a:srgbClr val="1E5AC8"/>
-                </a:solidFill>
-              </a:defRPr>
-            </a:pPr>
-            <a:r>
-              <a:t>🅰️ Gruppo A / Group A:</a:t>
-            </a:r>
             <a:br/>
             <a:r>
-              <a:t>Programma A: 200 salvati di sicuro.</a:t>
-            </a:r>
-            <a:br/>
-            <a:r>
-              <a:t>Programma B: 1/3 probabilità di salvare tutti e 600, 2/3 nessuno.</a:t>
-            </a:r>
-            <a:br/>
-          </a:p>
-          <a:p>
-            <a:pPr>
-              <a:defRPr sz="1200" b="1">
-                <a:solidFill>
-                  <a:srgbClr val="C8325A"/>
-                </a:solidFill>
-              </a:defRPr>
-            </a:pPr>
-            <a:r>
-              <a:t>🅱️ Gruppo B / Group B:</a:t>
-            </a:r>
-            <a:br/>
-            <a:r>
-              <a:t>Programma A: 400 morti di sicuro.</a:t>
-            </a:r>
-            <a:br/>
-            <a:r>
-              <a:t>Programma B: 1/3 probabilità che non muoia nessuno, 2/3 che muoiano tutti e 600.</a:t>
-            </a:r>
-            <a:br/>
+              <a:t>Inquadra il QR code con il tuo smartphone per scegliere il programma migliore secondo te.</a:t>
+            </a:r>
           </a:p>
         </p:txBody>
       </p:sp>
       <p:pic>
         <p:nvPicPr>
-          <p:cNvPr id="4" name="Picture 3" descr="Malattia_Asiatica.png"/>
+          <p:cNvPr id="5" name="Picture 4" descr="Malattia_Asiatica.png"/>
           <p:cNvPicPr>
             <a:picLocks noChangeAspect="1"/>
           </p:cNvPicPr>
@@ -6167,8 +6145,8 @@
         </p:blipFill>
         <p:spPr>
           <a:xfrm>
-            <a:off x="6035040" y="1645920"/>
-            <a:ext cx="2743200" cy="2743200"/>
+            <a:off x="5943600" y="1645920"/>
+            <a:ext cx="2926080" cy="2926080"/>
           </a:xfrm>
           <a:prstGeom prst="rect">
             <a:avLst/>
@@ -6177,14 +6155,14 @@
       </p:pic>
       <p:sp>
         <p:nvSpPr>
-          <p:cNvPr id="5" name="TextBox 4"/>
-          <p:cNvSpPr txBox="1"/>
-          <p:nvPr/>
-        </p:nvSpPr>
-        <p:spPr>
-          <a:xfrm>
-            <a:off x="5852160" y="4663440"/>
-            <a:ext cx="3108960" cy="1097280"/>
+          <p:cNvPr id="6" name="TextBox 5"/>
+          <p:cNvSpPr txBox="1"/>
+          <p:nvPr/>
+        </p:nvSpPr>
+        <p:spPr>
+          <a:xfrm>
+            <a:off x="5760720" y="4754880"/>
+            <a:ext cx="3291840" cy="1097280"/>
           </a:xfrm>
           <a:prstGeom prst="rect">
             <a:avLst/>
@@ -6258,7 +6236,7 @@
               </a:defRPr>
             </a:pPr>
             <a:r>
-              <a:t>3. Chirurgia Robotica AI — Framing Medico</a:t>
+              <a:t>3. Chirurgia Robotica con Intelligenza Artificiale</a:t>
             </a:r>
           </a:p>
         </p:txBody>
@@ -6271,8 +6249,8 @@
         </p:nvSpPr>
         <p:spPr>
           <a:xfrm>
-            <a:off x="548640" y="1188720"/>
-            <a:ext cx="5303520" cy="5029200"/>
+            <a:off x="548640" y="1005840"/>
+            <a:ext cx="8229600" cy="457200"/>
           </a:xfrm>
           <a:prstGeom prst="rect">
             <a:avLst/>
@@ -6286,68 +6264,65 @@
           <a:lstStyle/>
           <a:p>
             <a:pPr>
-              <a:defRPr sz="1300">
-                <a:solidFill>
-                  <a:srgbClr val="3C3C3C"/>
-                </a:solidFill>
-              </a:defRPr>
-            </a:pPr>
-            <a:r>
-              <a:t>📌 Scenario:</a:t>
+              <a:defRPr sz="1400" b="1">
+                <a:solidFill>
+                  <a:srgbClr val="FF6584"/>
+                </a:solidFill>
+              </a:defRPr>
+            </a:pPr>
+            <a:r>
+              <a:t>🧠 Bias Cognitivo: Framing Medico (Positive vs Negative Framing)</a:t>
+            </a:r>
+          </a:p>
+        </p:txBody>
+      </p:sp>
+      <p:sp>
+        <p:nvSpPr>
+          <p:cNvPr id="4" name="TextBox 3"/>
+          <p:cNvSpPr txBox="1"/>
+          <p:nvPr/>
+        </p:nvSpPr>
+        <p:spPr>
+          <a:xfrm>
+            <a:off x="548640" y="1645920"/>
+            <a:ext cx="5120640" cy="4572000"/>
+          </a:xfrm>
+          <a:prstGeom prst="rect">
+            <a:avLst/>
+          </a:prstGeom>
+          <a:noFill/>
+        </p:spPr>
+        <p:txBody>
+          <a:bodyPr wrap="square">
+            <a:spAutoFit/>
+          </a:bodyPr>
+          <a:lstStyle/>
+          <a:p>
+            <a:pPr>
+              <a:defRPr sz="1500">
+                <a:solidFill>
+                  <a:srgbClr val="323232"/>
+                </a:solidFill>
+              </a:defRPr>
+            </a:pPr>
+            <a:r>
+              <a:t>📌 Istruzioni &amp; Contesto:</a:t>
             </a:r>
             <a:br/>
             <a:r>
-              <a:t>Un software robotico AI deve eseguire un intervento su 100 pazienti critici.</a:t>
+              <a:t>Un nuovo software robotico AI deve eseguire un intervento chirurgico ad alto rischio su 100 pazienti in condizioni critiche.</a:t>
             </a:r>
             <a:br/>
-          </a:p>
-          <a:p>
-            <a:pPr>
-              <a:defRPr sz="1200" b="1">
-                <a:solidFill>
-                  <a:srgbClr val="1E5AC8"/>
-                </a:solidFill>
-              </a:defRPr>
-            </a:pPr>
-            <a:r>
-              <a:t>🅰️ Gruppo A / Group A:</a:t>
-            </a:r>
             <a:br/>
             <a:r>
-              <a:t>Dato statistico: 90 pazienti sopravviveranno.</a:t>
-            </a:r>
-            <a:br/>
-            <a:r>
-              <a:t>Autorizzi l'uso del software? (Sì / No)</a:t>
-            </a:r>
-            <a:br/>
-          </a:p>
-          <a:p>
-            <a:pPr>
-              <a:defRPr sz="1200" b="1">
-                <a:solidFill>
-                  <a:srgbClr val="C8325A"/>
-                </a:solidFill>
-              </a:defRPr>
-            </a:pPr>
-            <a:r>
-              <a:t>🅱️ Gruppo B / Group B:</a:t>
-            </a:r>
-            <a:br/>
-            <a:r>
-              <a:t>Dato statistico: 10 pazienti moriranno.</a:t>
-            </a:r>
-            <a:br/>
-            <a:r>
-              <a:t>Autorizzi l'uso del software? (Sì / No)</a:t>
-            </a:r>
-            <a:br/>
+              <a:t>Inquadra il QR code per leggere i dati statistici ed esprimere la tua decisione.</a:t>
+            </a:r>
           </a:p>
         </p:txBody>
       </p:sp>
       <p:pic>
         <p:nvPicPr>
-          <p:cNvPr id="4" name="Picture 3" descr="Framing_AI.png"/>
+          <p:cNvPr id="5" name="Picture 4" descr="Framing_AI.png"/>
           <p:cNvPicPr>
             <a:picLocks noChangeAspect="1"/>
           </p:cNvPicPr>
@@ -6361,8 +6336,8 @@
         </p:blipFill>
         <p:spPr>
           <a:xfrm>
-            <a:off x="6035040" y="1645920"/>
-            <a:ext cx="2743200" cy="2743200"/>
+            <a:off x="5943600" y="1645920"/>
+            <a:ext cx="2926080" cy="2926080"/>
           </a:xfrm>
           <a:prstGeom prst="rect">
             <a:avLst/>
@@ -6371,14 +6346,14 @@
       </p:pic>
       <p:sp>
         <p:nvSpPr>
-          <p:cNvPr id="5" name="TextBox 4"/>
-          <p:cNvSpPr txBox="1"/>
-          <p:nvPr/>
-        </p:nvSpPr>
-        <p:spPr>
-          <a:xfrm>
-            <a:off x="5852160" y="4663440"/>
-            <a:ext cx="3108960" cy="1097280"/>
+          <p:cNvPr id="6" name="TextBox 5"/>
+          <p:cNvSpPr txBox="1"/>
+          <p:nvPr/>
+        </p:nvSpPr>
+        <p:spPr>
+          <a:xfrm>
+            <a:off x="5760720" y="4754880"/>
+            <a:ext cx="3291840" cy="1097280"/>
           </a:xfrm>
           <a:prstGeom prst="rect">
             <a:avLst/>
@@ -6452,7 +6427,7 @@
               </a:defRPr>
             </a:pPr>
             <a:r>
-              <a:t>4. Ancoraggio — Età di Gandhi</a:t>
+              <a:t>4. Stima Biografica di Mahatma Gandhi</a:t>
             </a:r>
           </a:p>
         </p:txBody>
@@ -6465,8 +6440,8 @@
         </p:nvSpPr>
         <p:spPr>
           <a:xfrm>
-            <a:off x="548640" y="1188720"/>
-            <a:ext cx="5303520" cy="5029200"/>
+            <a:off x="548640" y="1005840"/>
+            <a:ext cx="8229600" cy="457200"/>
           </a:xfrm>
           <a:prstGeom prst="rect">
             <a:avLst/>
@@ -6480,68 +6455,65 @@
           <a:lstStyle/>
           <a:p>
             <a:pPr>
-              <a:defRPr sz="1300">
-                <a:solidFill>
-                  <a:srgbClr val="3C3C3C"/>
-                </a:solidFill>
-              </a:defRPr>
-            </a:pPr>
-            <a:r>
-              <a:t>📌 Scenario:</a:t>
+              <a:defRPr sz="1400" b="1">
+                <a:solidFill>
+                  <a:srgbClr val="FF6584"/>
+                </a:solidFill>
+              </a:defRPr>
+            </a:pPr>
+            <a:r>
+              <a:t>🧠 Bias Cognitivo: Effetto Ancoraggio (Anchoring Effect)</a:t>
+            </a:r>
+          </a:p>
+        </p:txBody>
+      </p:sp>
+      <p:sp>
+        <p:nvSpPr>
+          <p:cNvPr id="4" name="TextBox 3"/>
+          <p:cNvSpPr txBox="1"/>
+          <p:nvPr/>
+        </p:nvSpPr>
+        <p:spPr>
+          <a:xfrm>
+            <a:off x="548640" y="1645920"/>
+            <a:ext cx="5120640" cy="4572000"/>
+          </a:xfrm>
+          <a:prstGeom prst="rect">
+            <a:avLst/>
+          </a:prstGeom>
+          <a:noFill/>
+        </p:spPr>
+        <p:txBody>
+          <a:bodyPr wrap="square">
+            <a:spAutoFit/>
+          </a:bodyPr>
+          <a:lstStyle/>
+          <a:p>
+            <a:pPr>
+              <a:defRPr sz="1500">
+                <a:solidFill>
+                  <a:srgbClr val="323232"/>
+                </a:solidFill>
+              </a:defRPr>
+            </a:pPr>
+            <a:r>
+              <a:t>📌 Istruzioni &amp; Contesto:</a:t>
             </a:r>
             <a:br/>
             <a:r>
-              <a:t>Stima dell'età di morte di Mahatma Gandhi.</a:t>
+              <a:t>Mettiti alla prova con due domande sulla biografia e sulla storia di Mahatma Gandhi.</a:t>
             </a:r>
             <a:br/>
-          </a:p>
-          <a:p>
-            <a:pPr>
-              <a:defRPr sz="1200" b="1">
-                <a:solidFill>
-                  <a:srgbClr val="1E5AC8"/>
-                </a:solidFill>
-              </a:defRPr>
-            </a:pPr>
-            <a:r>
-              <a:t>🅰️ Gruppo A / Group A:</a:t>
-            </a:r>
             <a:br/>
             <a:r>
-              <a:t>1. Gandhi è morto prima o dopo i 114 anni?</a:t>
-            </a:r>
-            <a:br/>
-            <a:r>
-              <a:t>2. Stima l'età esatta alla morte (anni).</a:t>
-            </a:r>
-            <a:br/>
-          </a:p>
-          <a:p>
-            <a:pPr>
-              <a:defRPr sz="1200" b="1">
-                <a:solidFill>
-                  <a:srgbClr val="C8325A"/>
-                </a:solidFill>
-              </a:defRPr>
-            </a:pPr>
-            <a:r>
-              <a:t>🅱️ Gruppo B / Group B:</a:t>
-            </a:r>
-            <a:br/>
-            <a:r>
-              <a:t>1. Gandhi è morto prima o dopo i 35 anni?</a:t>
-            </a:r>
-            <a:br/>
-            <a:r>
-              <a:t>2. Stima l'età esatta alla morte (anni).</a:t>
-            </a:r>
-            <a:br/>
+              <a:t>Inquadra il QR code con il tuo smartphone per inserire la tua stima.</a:t>
+            </a:r>
           </a:p>
         </p:txBody>
       </p:sp>
       <p:pic>
         <p:nvPicPr>
-          <p:cNvPr id="4" name="Picture 3" descr="Ancoraggio_Gandhi.png"/>
+          <p:cNvPr id="5" name="Picture 4" descr="Ancoraggio_Gandhi.png"/>
           <p:cNvPicPr>
             <a:picLocks noChangeAspect="1"/>
           </p:cNvPicPr>
@@ -6555,8 +6527,8 @@
         </p:blipFill>
         <p:spPr>
           <a:xfrm>
-            <a:off x="6035040" y="1645920"/>
-            <a:ext cx="2743200" cy="2743200"/>
+            <a:off x="5943600" y="1645920"/>
+            <a:ext cx="2926080" cy="2926080"/>
           </a:xfrm>
           <a:prstGeom prst="rect">
             <a:avLst/>
@@ -6565,14 +6537,14 @@
       </p:pic>
       <p:sp>
         <p:nvSpPr>
-          <p:cNvPr id="5" name="TextBox 4"/>
-          <p:cNvSpPr txBox="1"/>
-          <p:nvPr/>
-        </p:nvSpPr>
-        <p:spPr>
-          <a:xfrm>
-            <a:off x="5852160" y="4663440"/>
-            <a:ext cx="3108960" cy="1097280"/>
+          <p:cNvPr id="6" name="TextBox 5"/>
+          <p:cNvSpPr txBox="1"/>
+          <p:nvPr/>
+        </p:nvSpPr>
+        <p:spPr>
+          <a:xfrm>
+            <a:off x="5760720" y="4754880"/>
+            <a:ext cx="3291840" cy="1097280"/>
           </a:xfrm>
           <a:prstGeom prst="rect">
             <a:avLst/>
@@ -6646,7 +6618,7 @@
               </a:defRPr>
             </a:pPr>
             <a:r>
-              <a:t>5. Ancoraggio Medico — Ruota della Fortuna</a:t>
+              <a:t>5. Valutazione Diagnostica Ospedaliera</a:t>
             </a:r>
           </a:p>
         </p:txBody>
@@ -6659,8 +6631,8 @@
         </p:nvSpPr>
         <p:spPr>
           <a:xfrm>
-            <a:off x="548640" y="1188720"/>
-            <a:ext cx="5303520" cy="5029200"/>
+            <a:off x="548640" y="1005840"/>
+            <a:ext cx="8229600" cy="457200"/>
           </a:xfrm>
           <a:prstGeom prst="rect">
             <a:avLst/>
@@ -6674,68 +6646,65 @@
           <a:lstStyle/>
           <a:p>
             <a:pPr>
-              <a:defRPr sz="1300">
-                <a:solidFill>
-                  <a:srgbClr val="3C3C3C"/>
-                </a:solidFill>
-              </a:defRPr>
-            </a:pPr>
-            <a:r>
-              <a:t>📌 Scenario:</a:t>
+              <a:defRPr sz="1400" b="1">
+                <a:solidFill>
+                  <a:srgbClr val="FF6584"/>
+                </a:solidFill>
+              </a:defRPr>
+            </a:pPr>
+            <a:r>
+              <a:t>🧠 Bias Cognitivo: Ancoraggio Numerico Irrilevante (Arbitrary Anchoring)</a:t>
+            </a:r>
+          </a:p>
+        </p:txBody>
+      </p:sp>
+      <p:sp>
+        <p:nvSpPr>
+          <p:cNvPr id="4" name="TextBox 3"/>
+          <p:cNvSpPr txBox="1"/>
+          <p:nvPr/>
+        </p:nvSpPr>
+        <p:spPr>
+          <a:xfrm>
+            <a:off x="548640" y="1645920"/>
+            <a:ext cx="5120640" cy="4572000"/>
+          </a:xfrm>
+          <a:prstGeom prst="rect">
+            <a:avLst/>
+          </a:prstGeom>
+          <a:noFill/>
+        </p:spPr>
+        <p:txBody>
+          <a:bodyPr wrap="square">
+            <a:spAutoFit/>
+          </a:bodyPr>
+          <a:lstStyle/>
+          <a:p>
+            <a:pPr>
+              <a:defRPr sz="1500">
+                <a:solidFill>
+                  <a:srgbClr val="323232"/>
+                </a:solidFill>
+              </a:defRPr>
+            </a:pPr>
+            <a:r>
+              <a:t>📌 Istruzioni &amp; Contesto:</a:t>
             </a:r>
             <a:br/>
             <a:r>
-              <a:t>Una ruota della fortuna estrae un numero prima della stima diagnostica.</a:t>
+              <a:t>Osserva il numero estratto dalla ruota della fortuna mostrata a lezione.</a:t>
             </a:r>
             <a:br/>
-          </a:p>
-          <a:p>
-            <a:pPr>
-              <a:defRPr sz="1200" b="1">
-                <a:solidFill>
-                  <a:srgbClr val="1E5AC8"/>
-                </a:solidFill>
-              </a:defRPr>
-            </a:pPr>
-            <a:r>
-              <a:t>🅰️ Gruppo A / Group A:</a:t>
-            </a:r>
             <a:br/>
             <a:r>
-              <a:t>Numero estratto dalla ruota: 12</a:t>
-            </a:r>
-            <a:br/>
-            <a:r>
-              <a:t>Domanda: Qual è la % di diagnosi errate dovute a stanchezza del medico?</a:t>
-            </a:r>
-            <a:br/>
-          </a:p>
-          <a:p>
-            <a:pPr>
-              <a:defRPr sz="1200" b="1">
-                <a:solidFill>
-                  <a:srgbClr val="C8325A"/>
-                </a:solidFill>
-              </a:defRPr>
-            </a:pPr>
-            <a:r>
-              <a:t>🅱️ Gruppo B / Group B:</a:t>
-            </a:r>
-            <a:br/>
-            <a:r>
-              <a:t>Numero estratto dalla ruota: 65</a:t>
-            </a:r>
-            <a:br/>
-            <a:r>
-              <a:t>Domanda: Qual è la % di diagnosi errate dovute a stanchezza del medico?</a:t>
-            </a:r>
-            <a:br/>
+              <a:t>Successivamente, inquadra il QR code per fornire la tua stima sulla percentuale di diagnosi errate in ospedale.</a:t>
+            </a:r>
           </a:p>
         </p:txBody>
       </p:sp>
       <p:pic>
         <p:nvPicPr>
-          <p:cNvPr id="4" name="Picture 3" descr="Ancoraggio_Roulette.png"/>
+          <p:cNvPr id="5" name="Picture 4" descr="Ancoraggio_Roulette.png"/>
           <p:cNvPicPr>
             <a:picLocks noChangeAspect="1"/>
           </p:cNvPicPr>
@@ -6749,8 +6718,8 @@
         </p:blipFill>
         <p:spPr>
           <a:xfrm>
-            <a:off x="6035040" y="1645920"/>
-            <a:ext cx="2743200" cy="2743200"/>
+            <a:off x="5943600" y="1645920"/>
+            <a:ext cx="2926080" cy="2926080"/>
           </a:xfrm>
           <a:prstGeom prst="rect">
             <a:avLst/>
@@ -6759,14 +6728,14 @@
       </p:pic>
       <p:sp>
         <p:nvSpPr>
-          <p:cNvPr id="5" name="TextBox 4"/>
-          <p:cNvSpPr txBox="1"/>
-          <p:nvPr/>
-        </p:nvSpPr>
-        <p:spPr>
-          <a:xfrm>
-            <a:off x="5852160" y="4663440"/>
-            <a:ext cx="3108960" cy="1097280"/>
+          <p:cNvPr id="6" name="TextBox 5"/>
+          <p:cNvSpPr txBox="1"/>
+          <p:nvPr/>
+        </p:nvSpPr>
+        <p:spPr>
+          <a:xfrm>
+            <a:off x="5760720" y="4754880"/>
+            <a:ext cx="3291840" cy="1097280"/>
           </a:xfrm>
           <a:prstGeom prst="rect">
             <a:avLst/>
@@ -6840,7 +6809,7 @@
               </a:defRPr>
             </a:pPr>
             <a:r>
-              <a:t>6. Avversione alle Perdite — Scelte Finanziarie</a:t>
+              <a:t>6. Decisione Finanziaria e Rischio</a:t>
             </a:r>
           </a:p>
         </p:txBody>
@@ -6853,8 +6822,8 @@
         </p:nvSpPr>
         <p:spPr>
           <a:xfrm>
-            <a:off x="548640" y="1188720"/>
-            <a:ext cx="5303520" cy="5029200"/>
+            <a:off x="548640" y="1005840"/>
+            <a:ext cx="8229600" cy="457200"/>
           </a:xfrm>
           <a:prstGeom prst="rect">
             <a:avLst/>
@@ -6868,76 +6837,65 @@
           <a:lstStyle/>
           <a:p>
             <a:pPr>
-              <a:defRPr sz="1300">
-                <a:solidFill>
-                  <a:srgbClr val="3C3C3C"/>
-                </a:solidFill>
-              </a:defRPr>
-            </a:pPr>
-            <a:r>
-              <a:t>📌 Scenario:</a:t>
+              <a:defRPr sz="1400" b="1">
+                <a:solidFill>
+                  <a:srgbClr val="FF6584"/>
+                </a:solidFill>
+              </a:defRPr>
+            </a:pPr>
+            <a:r>
+              <a:t>🧠 Bias Cognitivo: Avversione alle Perdite &amp; Teoria del Prospetto (Loss Aversion)</a:t>
+            </a:r>
+          </a:p>
+        </p:txBody>
+      </p:sp>
+      <p:sp>
+        <p:nvSpPr>
+          <p:cNvPr id="4" name="TextBox 3"/>
+          <p:cNvSpPr txBox="1"/>
+          <p:nvPr/>
+        </p:nvSpPr>
+        <p:spPr>
+          <a:xfrm>
+            <a:off x="548640" y="1645920"/>
+            <a:ext cx="5120640" cy="4572000"/>
+          </a:xfrm>
+          <a:prstGeom prst="rect">
+            <a:avLst/>
+          </a:prstGeom>
+          <a:noFill/>
+        </p:spPr>
+        <p:txBody>
+          <a:bodyPr wrap="square">
+            <a:spAutoFit/>
+          </a:bodyPr>
+          <a:lstStyle/>
+          <a:p>
+            <a:pPr>
+              <a:defRPr sz="1500">
+                <a:solidFill>
+                  <a:srgbClr val="323232"/>
+                </a:solidFill>
+              </a:defRPr>
+            </a:pPr>
+            <a:r>
+              <a:t>📌 Istruzioni &amp; Contesto:</a:t>
             </a:r>
             <a:br/>
             <a:r>
-              <a:t>Valutazione del rischio tra vincite certe e perdite certe.</a:t>
+              <a:t>Ti viene proposto uno scenario economico con un premio iniziale e due opzioni finanziarie alternative.</a:t>
             </a:r>
             <a:br/>
-          </a:p>
-          <a:p>
-            <a:pPr>
-              <a:defRPr sz="1200" b="1">
-                <a:solidFill>
-                  <a:srgbClr val="1E5AC8"/>
-                </a:solidFill>
-              </a:defRPr>
-            </a:pPr>
-            <a:r>
-              <a:t>🅰️ Gruppo A / Group A:</a:t>
-            </a:r>
             <a:br/>
             <a:r>
-              <a:t>Ricevi 1.000€.</a:t>
-            </a:r>
-            <a:br/>
-            <a:r>
-              <a:t>A) Vinci altri 500€ sicuri (100%)</a:t>
-            </a:r>
-            <a:br/>
-            <a:r>
-              <a:t>B) Lancio moneta: 50% vinci 1.000€, 50% vinci 0€</a:t>
-            </a:r>
-            <a:br/>
-          </a:p>
-          <a:p>
-            <a:pPr>
-              <a:defRPr sz="1200" b="1">
-                <a:solidFill>
-                  <a:srgbClr val="C8325A"/>
-                </a:solidFill>
-              </a:defRPr>
-            </a:pPr>
-            <a:r>
-              <a:t>🅱️ Gruppo B / Group B:</a:t>
-            </a:r>
-            <a:br/>
-            <a:r>
-              <a:t>Ricevi 2.000€.</a:t>
-            </a:r>
-            <a:br/>
-            <a:r>
-              <a:t>A) Perdi 500€ sicuri (100%)</a:t>
-            </a:r>
-            <a:br/>
-            <a:r>
-              <a:t>B) Lancio moneta: 50% perdi 1.000€, 50% perdi 0€</a:t>
-            </a:r>
-            <a:br/>
+              <a:t>Inquadra il QR code dal tuo smartphone per scegliere l'opzione che preferisci.</a:t>
+            </a:r>
           </a:p>
         </p:txBody>
       </p:sp>
       <p:pic>
         <p:nvPicPr>
-          <p:cNvPr id="4" name="Picture 3" descr="Avversione_Perdite.png"/>
+          <p:cNvPr id="5" name="Picture 4" descr="Avversione_Perdite.png"/>
           <p:cNvPicPr>
             <a:picLocks noChangeAspect="1"/>
           </p:cNvPicPr>
@@ -6951,8 +6909,8 @@
         </p:blipFill>
         <p:spPr>
           <a:xfrm>
-            <a:off x="6035040" y="1645920"/>
-            <a:ext cx="2743200" cy="2743200"/>
+            <a:off x="5943600" y="1645920"/>
+            <a:ext cx="2926080" cy="2926080"/>
           </a:xfrm>
           <a:prstGeom prst="rect">
             <a:avLst/>
@@ -6961,14 +6919,14 @@
       </p:pic>
       <p:sp>
         <p:nvSpPr>
-          <p:cNvPr id="5" name="TextBox 4"/>
-          <p:cNvSpPr txBox="1"/>
-          <p:nvPr/>
-        </p:nvSpPr>
-        <p:spPr>
-          <a:xfrm>
-            <a:off x="5852160" y="4663440"/>
-            <a:ext cx="3108960" cy="1097280"/>
+          <p:cNvPr id="6" name="TextBox 5"/>
+          <p:cNvSpPr txBox="1"/>
+          <p:nvPr/>
+        </p:nvSpPr>
+        <p:spPr>
+          <a:xfrm>
+            <a:off x="5760720" y="4754880"/>
+            <a:ext cx="3291840" cy="1097280"/>
           </a:xfrm>
           <a:prstGeom prst="rect">
             <a:avLst/>
@@ -7042,7 +7000,7 @@
               </a:defRPr>
             </a:pPr>
             <a:r>
-              <a:t>7. Illusione di Verità — Effetto Font</a:t>
+              <a:t>7. Valutazione dell'Affermazione Scientifica</a:t>
             </a:r>
           </a:p>
         </p:txBody>
@@ -7055,8 +7013,8 @@
         </p:nvSpPr>
         <p:spPr>
           <a:xfrm>
-            <a:off x="548640" y="1188720"/>
-            <a:ext cx="5303520" cy="5029200"/>
+            <a:off x="548640" y="1005840"/>
+            <a:ext cx="8229600" cy="457200"/>
           </a:xfrm>
           <a:prstGeom prst="rect">
             <a:avLst/>
@@ -7070,76 +7028,60 @@
           <a:lstStyle/>
           <a:p>
             <a:pPr>
-              <a:defRPr sz="1300">
-                <a:solidFill>
-                  <a:srgbClr val="3C3C3C"/>
-                </a:solidFill>
-              </a:defRPr>
-            </a:pPr>
-            <a:r>
-              <a:t>📌 Scenario:</a:t>
+              <a:defRPr sz="1400" b="1">
+                <a:solidFill>
+                  <a:srgbClr val="FF6584"/>
+                </a:solidFill>
+              </a:defRPr>
+            </a:pPr>
+            <a:r>
+              <a:t>🧠 Bias Cognitivo: Illusione di Verità &amp; Fluidità Cognitiva (Illusion of Truth)</a:t>
+            </a:r>
+          </a:p>
+        </p:txBody>
+      </p:sp>
+      <p:sp>
+        <p:nvSpPr>
+          <p:cNvPr id="4" name="TextBox 3"/>
+          <p:cNvSpPr txBox="1"/>
+          <p:nvPr/>
+        </p:nvSpPr>
+        <p:spPr>
+          <a:xfrm>
+            <a:off x="548640" y="1645920"/>
+            <a:ext cx="5120640" cy="4572000"/>
+          </a:xfrm>
+          <a:prstGeom prst="rect">
+            <a:avLst/>
+          </a:prstGeom>
+          <a:noFill/>
+        </p:spPr>
+        <p:txBody>
+          <a:bodyPr wrap="square">
+            <a:spAutoFit/>
+          </a:bodyPr>
+          <a:lstStyle/>
+          <a:p>
+            <a:pPr>
+              <a:defRPr sz="1500">
+                <a:solidFill>
+                  <a:srgbClr val="323232"/>
+                </a:solidFill>
+              </a:defRPr>
+            </a:pPr>
+            <a:r>
+              <a:t>📌 Istruzioni &amp; Contesto:</a:t>
             </a:r>
             <a:br/>
             <a:r>
-              <a:t>Valutazione affermazione: 'L'assunzione di Omega-3 riduce del 15% le infiammazioni corporee.'</a:t>
-            </a:r>
-            <a:br/>
-          </a:p>
-          <a:p>
-            <a:pPr>
-              <a:defRPr sz="1200" b="1">
-                <a:solidFill>
-                  <a:srgbClr val="1E5AC8"/>
-                </a:solidFill>
-              </a:defRPr>
-            </a:pPr>
-            <a:r>
-              <a:t>🅰️ Gruppo A / Group A:</a:t>
-            </a:r>
-            <a:br/>
-            <a:r>
-              <a:t>Formattazione: Arial grassetto nero ad alta visibilità.</a:t>
-            </a:r>
-            <a:br/>
-          </a:p>
-          <a:p>
-            <a:pPr>
-              <a:defRPr sz="1200" b="1">
-                <a:solidFill>
-                  <a:srgbClr val="C8325A"/>
-                </a:solidFill>
-              </a:defRPr>
-            </a:pPr>
-            <a:r>
-              <a:t>🅱️ Gruppo B / Group B:</a:t>
-            </a:r>
-            <a:br/>
-            <a:r>
-              <a:t>Formattazione: Comic Sans sbiadito grigio a bassa visibilità.</a:t>
-            </a:r>
-            <a:br/>
-          </a:p>
-          <a:p>
-            <a:pPr>
-              <a:defRPr sz="1100" i="1">
-                <a:solidFill>
-                  <a:srgbClr val="646464"/>
-                </a:solidFill>
-              </a:defRPr>
-            </a:pPr>
-            <a:r>
-              <a:t>💡 Extra:</a:t>
-            </a:r>
-            <a:br/>
-            <a:r>
-              <a:t>Domanda: Da 1 a 10, quanto ti sembra vera e scientifica questa frase?</a:t>
+              <a:t>Inquadra il QR code con la fotocamera del tuo smartphone per leggere l'affermazione scientifica proposta e valutare da 1 a 10 quanto ti sembra vera.</a:t>
             </a:r>
           </a:p>
         </p:txBody>
       </p:sp>
       <p:pic>
         <p:nvPicPr>
-          <p:cNvPr id="4" name="Picture 3" descr="Illusione_Verita.png"/>
+          <p:cNvPr id="5" name="Picture 4" descr="Illusione_Verita.png"/>
           <p:cNvPicPr>
             <a:picLocks noChangeAspect="1"/>
           </p:cNvPicPr>
@@ -7153,8 +7095,8 @@
         </p:blipFill>
         <p:spPr>
           <a:xfrm>
-            <a:off x="6035040" y="1645920"/>
-            <a:ext cx="2743200" cy="2743200"/>
+            <a:off x="5943600" y="1645920"/>
+            <a:ext cx="2926080" cy="2926080"/>
           </a:xfrm>
           <a:prstGeom prst="rect">
             <a:avLst/>
@@ -7163,14 +7105,14 @@
       </p:pic>
       <p:sp>
         <p:nvSpPr>
-          <p:cNvPr id="5" name="TextBox 4"/>
-          <p:cNvSpPr txBox="1"/>
-          <p:nvPr/>
-        </p:nvSpPr>
-        <p:spPr>
-          <a:xfrm>
-            <a:off x="5852160" y="4663440"/>
-            <a:ext cx="3108960" cy="1097280"/>
+          <p:cNvPr id="6" name="TextBox 5"/>
+          <p:cNvSpPr txBox="1"/>
+          <p:nvPr/>
+        </p:nvSpPr>
+        <p:spPr>
+          <a:xfrm>
+            <a:off x="5760720" y="4754880"/>
+            <a:ext cx="3291840" cy="1097280"/>
           </a:xfrm>
           <a:prstGeom prst="rect">
             <a:avLst/>
@@ -7244,7 +7186,7 @@
               </a:defRPr>
             </a:pPr>
             <a:r>
-              <a:t>8. Availability Heuristic — Euristica della Disponibilità</a:t>
+              <a:t>8. Inventario della Personalità (Assertività)</a:t>
             </a:r>
           </a:p>
         </p:txBody>
@@ -7257,8 +7199,8 @@
         </p:nvSpPr>
         <p:spPr>
           <a:xfrm>
-            <a:off x="548640" y="1188720"/>
-            <a:ext cx="5303520" cy="5029200"/>
+            <a:off x="548640" y="1005840"/>
+            <a:ext cx="8229600" cy="457200"/>
           </a:xfrm>
           <a:prstGeom prst="rect">
             <a:avLst/>
@@ -7272,68 +7214,60 @@
           <a:lstStyle/>
           <a:p>
             <a:pPr>
-              <a:defRPr sz="1300">
-                <a:solidFill>
-                  <a:srgbClr val="3C3C3C"/>
-                </a:solidFill>
-              </a:defRPr>
-            </a:pPr>
-            <a:r>
-              <a:t>📌 Scenario:</a:t>
+              <a:defRPr sz="1400" b="1">
+                <a:solidFill>
+                  <a:srgbClr val="FF6584"/>
+                </a:solidFill>
+              </a:defRPr>
+            </a:pPr>
+            <a:r>
+              <a:t>🧠 Bias Cognitivo: Euristica della Disponibilità &amp; Sforzo Cognitivo (Availability Heuristic)</a:t>
+            </a:r>
+          </a:p>
+        </p:txBody>
+      </p:sp>
+      <p:sp>
+        <p:nvSpPr>
+          <p:cNvPr id="4" name="TextBox 3"/>
+          <p:cNvSpPr txBox="1"/>
+          <p:nvPr/>
+        </p:nvSpPr>
+        <p:spPr>
+          <a:xfrm>
+            <a:off x="548640" y="1645920"/>
+            <a:ext cx="5120640" cy="4572000"/>
+          </a:xfrm>
+          <a:prstGeom prst="rect">
+            <a:avLst/>
+          </a:prstGeom>
+          <a:noFill/>
+        </p:spPr>
+        <p:txBody>
+          <a:bodyPr wrap="square">
+            <a:spAutoFit/>
+          </a:bodyPr>
+          <a:lstStyle/>
+          <a:p>
+            <a:pPr>
+              <a:defRPr sz="1500">
+                <a:solidFill>
+                  <a:srgbClr val="323232"/>
+                </a:solidFill>
+              </a:defRPr>
+            </a:pPr>
+            <a:r>
+              <a:t>📌 Istruzioni &amp; Contesto:</a:t>
             </a:r>
             <a:br/>
             <a:r>
-              <a:t>Richiamo alla memoria di comportamenti assertivi.</a:t>
-            </a:r>
-            <a:br/>
-          </a:p>
-          <a:p>
-            <a:pPr>
-              <a:defRPr sz="1200" b="1">
-                <a:solidFill>
-                  <a:srgbClr val="1E5AC8"/>
-                </a:solidFill>
-              </a:defRPr>
-            </a:pPr>
-            <a:r>
-              <a:t>🅰️ Gruppo A / Group A:</a:t>
-            </a:r>
-            <a:br/>
-            <a:r>
-              <a:t>1. Elenca 2 situazioni in cui sei stato assertivo.</a:t>
-            </a:r>
-            <a:br/>
-            <a:r>
-              <a:t>2. Valuta quanto ti ritieni assertivo (1-10).</a:t>
-            </a:r>
-            <a:br/>
-          </a:p>
-          <a:p>
-            <a:pPr>
-              <a:defRPr sz="1200" b="1">
-                <a:solidFill>
-                  <a:srgbClr val="C8325A"/>
-                </a:solidFill>
-              </a:defRPr>
-            </a:pPr>
-            <a:r>
-              <a:t>🅱️ Gruppo B / Group B:</a:t>
-            </a:r>
-            <a:br/>
-            <a:r>
-              <a:t>1. Elenca 12 situazioni in cui sei stato assertivo.</a:t>
-            </a:r>
-            <a:br/>
-            <a:r>
-              <a:t>2. Valuta quanto ti ritieni assertivo (1-10).</a:t>
-            </a:r>
-            <a:br/>
+              <a:t>Inquadra il QR code dal tuo smartphone per completare un breve esercizio di memoria sui tuoi comportamenti passati e valutare il tuo livello personale di assertività.</a:t>
+            </a:r>
           </a:p>
         </p:txBody>
       </p:sp>
       <p:pic>
         <p:nvPicPr>
-          <p:cNvPr id="4" name="Picture 3" descr="Euristica_Disponibilita.png"/>
+          <p:cNvPr id="5" name="Picture 4" descr="Euristica_Disponibilita.png"/>
           <p:cNvPicPr>
             <a:picLocks noChangeAspect="1"/>
           </p:cNvPicPr>
@@ -7347,8 +7281,8 @@
         </p:blipFill>
         <p:spPr>
           <a:xfrm>
-            <a:off x="6035040" y="1645920"/>
-            <a:ext cx="2743200" cy="2743200"/>
+            <a:off x="5943600" y="1645920"/>
+            <a:ext cx="2926080" cy="2926080"/>
           </a:xfrm>
           <a:prstGeom prst="rect">
             <a:avLst/>
@@ -7357,14 +7291,14 @@
       </p:pic>
       <p:sp>
         <p:nvSpPr>
-          <p:cNvPr id="5" name="TextBox 4"/>
-          <p:cNvSpPr txBox="1"/>
-          <p:nvPr/>
-        </p:nvSpPr>
-        <p:spPr>
-          <a:xfrm>
-            <a:off x="5852160" y="4663440"/>
-            <a:ext cx="3108960" cy="1097280"/>
+          <p:cNvPr id="6" name="TextBox 5"/>
+          <p:cNvSpPr txBox="1"/>
+          <p:nvPr/>
+        </p:nvSpPr>
+        <p:spPr>
+          <a:xfrm>
+            <a:off x="5760720" y="4754880"/>
+            <a:ext cx="3291840" cy="1097280"/>
           </a:xfrm>
           <a:prstGeom prst="rect">
             <a:avLst/>

</xml_diff>

<commit_message>
Replace experiment 18 with Bruner & Potter Bruner-Potter / WYSIATI experiment (Fire Hydrant vs Minion)
</commit_message>
<xml_diff>
--- a/QR_Esperimenti_Bias_Domande_IT.pptx
+++ b/QR_Esperimenti_Bias_Domande_IT.pptx
@@ -4909,7 +4909,7 @@
               </a:defRPr>
             </a:pPr>
             <a:r>
-              <a:t>18. Verdetto in un Processo Penale</a:t>
+              <a:t>18. WYSIATI — Persistenza dell'Ipotesi (Bruner &amp; Potter)</a:t>
             </a:r>
           </a:p>
         </p:txBody>
@@ -4944,7 +4944,7 @@
               </a:defRPr>
             </a:pPr>
             <a:r>
-              <a:t>🧠 Bias Cognitivo: WYSIATI - What You See Is All There Is (Kahneman)</a:t>
+              <a:t>🧠 Bias Cognitivo: WYSIATI ('What You See Is All There Is') &amp; Bias di Conferma Visivo</a:t>
             </a:r>
           </a:p>
         </p:txBody>
@@ -4983,7 +4983,12 @@
             </a:r>
             <a:br/>
             <a:r>
-              <a:t>Inquadra il QR code per leggere la testimonianza presentata al processo giudiziario e indicare il tuo verdetto di colpevolezza e il tuo livello di sicurezza.</a:t>
+              <a:t>Guarda con attenzione l'immagine visiva mostrata sul tuo smartphone dopo aver inquadrato il QR code.</a:t>
+            </a:r>
+            <a:br/>
+            <a:br/>
+            <a:r>
+              <a:t>Indica cosa ritieni rappresenti principalmente l'immagine (es. Un Minion vs Un Idrante/Estintore).</a:t>
             </a:r>
           </a:p>
         </p:txBody>

</xml_diff>

<commit_message>
Add Experiment 23: Wason 2-4-6 Confirmation Bias task to Streamlit app, dashboard and PowerPoint slides
</commit_message>
<xml_diff>
--- a/QR_Esperimenti_Bias_Domande_IT.pptx
+++ b/QR_Esperimenti_Bias_Domande_IT.pptx
@@ -28,6 +28,7 @@
     <p:sldId id="276" r:id="rId27"/>
     <p:sldId id="277" r:id="rId28"/>
     <p:sldId id="278" r:id="rId29"/>
+    <p:sldId id="279" r:id="rId30"/>
   </p:sldIdLst>
   <p:sldSz cx="9144000" cy="6858000" type="screen4x3"/>
   <p:notesSz cx="6858000" cy="9144000"/>
@@ -5946,6 +5947,197 @@
       <p:pic>
         <p:nvPicPr>
           <p:cNvPr id="5" name="Picture 4" descr="Regressione_Media.png"/>
+          <p:cNvPicPr>
+            <a:picLocks noChangeAspect="1"/>
+          </p:cNvPicPr>
+          <p:nvPr/>
+        </p:nvPicPr>
+        <p:blipFill>
+          <a:blip r:embed="rId2"/>
+          <a:stretch>
+            <a:fillRect/>
+          </a:stretch>
+        </p:blipFill>
+        <p:spPr>
+          <a:xfrm>
+            <a:off x="5943600" y="1645920"/>
+            <a:ext cx="2926080" cy="2926080"/>
+          </a:xfrm>
+          <a:prstGeom prst="rect">
+            <a:avLst/>
+          </a:prstGeom>
+        </p:spPr>
+      </p:pic>
+      <p:sp>
+        <p:nvSpPr>
+          <p:cNvPr id="6" name="TextBox 5"/>
+          <p:cNvSpPr txBox="1"/>
+          <p:nvPr/>
+        </p:nvSpPr>
+        <p:spPr>
+          <a:xfrm>
+            <a:off x="5760720" y="4754880"/>
+            <a:ext cx="3291840" cy="1097280"/>
+          </a:xfrm>
+          <a:prstGeom prst="rect">
+            <a:avLst/>
+          </a:prstGeom>
+          <a:noFill/>
+        </p:spPr>
+        <p:txBody>
+          <a:bodyPr wrap="square">
+            <a:spAutoFit/>
+          </a:bodyPr>
+          <a:lstStyle/>
+          <a:p>
+            <a:pPr algn="ctr">
+              <a:defRPr sz="1400" b="1">
+                <a:solidFill>
+                  <a:srgbClr val="6C63FF"/>
+                </a:solidFill>
+              </a:defRPr>
+            </a:pPr>
+            <a:r>
+              <a:t>📱 Inquadra il QR code con la tua fotocamera per partecipare</a:t>
+            </a:r>
+          </a:p>
+        </p:txBody>
+      </p:sp>
+    </p:spTree>
+  </p:cSld>
+  <p:clrMapOvr>
+    <a:masterClrMapping/>
+  </p:clrMapOvr>
+</p:sld>
+</file>
+
+<file path=ppt/slides/slide24.xml><?xml version="1.0" encoding="utf-8"?>
+<p:sld xmlns:a="http://schemas.openxmlformats.org/drawingml/2006/main" xmlns:p="http://schemas.openxmlformats.org/presentationml/2006/main" xmlns:r="http://schemas.openxmlformats.org/officeDocument/2006/relationships">
+  <p:cSld>
+    <p:spTree>
+      <p:nvGrpSpPr>
+        <p:cNvPr id="1" name=""/>
+        <p:cNvGrpSpPr/>
+        <p:nvPr/>
+      </p:nvGrpSpPr>
+      <p:grpSpPr/>
+      <p:sp>
+        <p:nvSpPr>
+          <p:cNvPr id="2" name="TextBox 1"/>
+          <p:cNvSpPr txBox="1"/>
+          <p:nvPr/>
+        </p:nvSpPr>
+        <p:spPr>
+          <a:xfrm>
+            <a:off x="548640" y="365760"/>
+            <a:ext cx="8229600" cy="731520"/>
+          </a:xfrm>
+          <a:prstGeom prst="rect">
+            <a:avLst/>
+          </a:prstGeom>
+          <a:noFill/>
+        </p:spPr>
+        <p:txBody>
+          <a:bodyPr wrap="square">
+            <a:spAutoFit/>
+          </a:bodyPr>
+          <a:lstStyle/>
+          <a:p>
+            <a:pPr>
+              <a:defRPr sz="2200" b="1">
+                <a:solidFill>
+                  <a:srgbClr val="6C63FF"/>
+                </a:solidFill>
+              </a:defRPr>
+            </a:pPr>
+            <a:r>
+              <a:t>23. Il Compito 2 - 4 - 6</a:t>
+            </a:r>
+          </a:p>
+        </p:txBody>
+      </p:sp>
+      <p:sp>
+        <p:nvSpPr>
+          <p:cNvPr id="3" name="TextBox 2"/>
+          <p:cNvSpPr txBox="1"/>
+          <p:nvPr/>
+        </p:nvSpPr>
+        <p:spPr>
+          <a:xfrm>
+            <a:off x="548640" y="1005840"/>
+            <a:ext cx="8229600" cy="457200"/>
+          </a:xfrm>
+          <a:prstGeom prst="rect">
+            <a:avLst/>
+          </a:prstGeom>
+          <a:noFill/>
+        </p:spPr>
+        <p:txBody>
+          <a:bodyPr wrap="square">
+            <a:spAutoFit/>
+          </a:bodyPr>
+          <a:lstStyle/>
+          <a:p>
+            <a:pPr>
+              <a:defRPr sz="1400" b="1">
+                <a:solidFill>
+                  <a:srgbClr val="FF6584"/>
+                </a:solidFill>
+              </a:defRPr>
+            </a:pPr>
+            <a:r>
+              <a:t>🧠 Bias Cognitivo: Bias di Conferma / Verifica delle Ipotesi (Wason, 1960)</a:t>
+            </a:r>
+          </a:p>
+        </p:txBody>
+      </p:sp>
+      <p:sp>
+        <p:nvSpPr>
+          <p:cNvPr id="4" name="TextBox 3"/>
+          <p:cNvSpPr txBox="1"/>
+          <p:nvPr/>
+        </p:nvSpPr>
+        <p:spPr>
+          <a:xfrm>
+            <a:off x="548640" y="1645920"/>
+            <a:ext cx="5120640" cy="4572000"/>
+          </a:xfrm>
+          <a:prstGeom prst="rect">
+            <a:avLst/>
+          </a:prstGeom>
+          <a:noFill/>
+        </p:spPr>
+        <p:txBody>
+          <a:bodyPr wrap="square">
+            <a:spAutoFit/>
+          </a:bodyPr>
+          <a:lstStyle/>
+          <a:p>
+            <a:pPr>
+              <a:defRPr sz="1500">
+                <a:solidFill>
+                  <a:srgbClr val="323232"/>
+                </a:solidFill>
+              </a:defRPr>
+            </a:pPr>
+            <a:r>
+              <a:t>📌 Istruzioni &amp; Contesto:</a:t>
+            </a:r>
+            <a:br/>
+            <a:r>
+              <a:t>Ti viene mostrata la sequenza numerica 2 - 4 - 6, che segue una regola segreta inventata dal docente.</a:t>
+            </a:r>
+            <a:br/>
+            <a:br/>
+            <a:r>
+              <a:t>Inquadra il QR code per scegliere la terzetta di numeri che intendi testare per scoprire la regola.</a:t>
+            </a:r>
+          </a:p>
+        </p:txBody>
+      </p:sp>
+      <p:pic>
+        <p:nvPicPr>
+          <p:cNvPr id="5" name="Picture 4" descr="Bias_Conferma_Wason.png"/>
           <p:cNvPicPr>
             <a:picLocks noChangeAspect="1"/>
           </p:cNvPicPr>

</xml_diff>

<commit_message>
Add explicit instruction 'Respond AS SOON AS POSSIBLE as soon as you think you recognize the image' to page 18 and PPT slides
</commit_message>
<xml_diff>
--- a/QR_Esperimenti_Bias_Domande_IT.pptx
+++ b/QR_Esperimenti_Bias_Domande_IT.pptx
@@ -4984,12 +4984,12 @@
             </a:r>
             <a:br/>
             <a:r>
-              <a:t>Guarda con attenzione l'immagine visiva mostrata sul tuo smartphone dopo aver inquadrato il QR code.</a:t>
+              <a:t>Guarda con attenzione la sequenza visiva mostrata sul tuo smartphone dopo aver inquadrato il QR code.</a:t>
             </a:r>
             <a:br/>
             <a:br/>
             <a:r>
-              <a:t>Nel Gruppo A l'immagine ha una transizione fluida e continua (video di 8s); nel Gruppo B si mostra attraverso 4 frame discreti presi dal processo di messa a fuoco (scatti netti ogni 2s).</a:t>
+              <a:t>⚡ IMPORTANTISSIMO: Seleziona e invia la tua risposta il PRIMA POSSIBILE non appena pensi di aver riconosciuto cosa raffigura l'immagine!</a:t>
             </a:r>
           </a:p>
         </p:txBody>

</xml_diff>

<commit_message>
Replace multiple choice with open text field for experiment 18 to capture unguided first impression
</commit_message>
<xml_diff>
--- a/QR_Esperimenti_Bias_Domande_IT.pptx
+++ b/QR_Esperimenti_Bias_Domande_IT.pptx
@@ -4984,12 +4984,12 @@
             </a:r>
             <a:br/>
             <a:r>
-              <a:t>Guarda con attenzione la sequenza visiva mostrata sul tuo smartphone dopo aver inquadrato il QR code.</a:t>
+              <a:t>Guarda la sequenza visiva sul tuo smartphone dopo aver inquadrato il QR code.</a:t>
             </a:r>
             <a:br/>
             <a:br/>
             <a:r>
-              <a:t>⚡ IMPORTANTISSIMO: Seleziona e invia la tua risposta il PRIMA POSSIBILE non appena pensi di aver riconosciuto cosa raffigura l'immagine!</a:t>
+              <a:t>⚡ IMPORTANTISSIMO: Non ci sono opzioni a scelta multipla! Scrivi nello spazio sul tuo smartphone LA PRIMA COSA CHE VEDI (la tua primissima impressione non appena l'immagine compare) e invia subito!</a:t>
             </a:r>
           </a:p>
         </p:txBody>

</xml_diff>

<commit_message>
Update Gandhi references to use 'Gandhi' instead of 'Mahatma Gandhi'
</commit_message>
<xml_diff>
--- a/QR_Esperimenti_Bias_Domande_IT.pptx
+++ b/QR_Esperimenti_Bias_Domande_IT.pptx
@@ -6624,7 +6624,7 @@
               </a:defRPr>
             </a:pPr>
             <a:r>
-              <a:t>4. Stima Biografica di Mahatma Gandhi</a:t>
+              <a:t>4. Stima Biografica di Gandhi</a:t>
             </a:r>
           </a:p>
         </p:txBody>
@@ -6659,7 +6659,7 @@
               </a:defRPr>
             </a:pPr>
             <a:r>
-              <a:t>🧠 Bias Cognitivo: Effetto Ancoraggio (Anchoring Effect)</a:t>
+              <a:t>🧠 Bias Cognitivo: Effetto Ancoraggio / Valutazione di Riferimento (Anchoring Effect)</a:t>
             </a:r>
           </a:p>
         </p:txBody>
@@ -6698,7 +6698,7 @@
             </a:r>
             <a:br/>
             <a:r>
-              <a:t>Mettiti alla prova con due domande sulla biografia e sulla storia di Mahatma Gandhi.</a:t>
+              <a:t>Mettiti alla prova con due domande sulla biografia e sulla storia di Gandhi.</a:t>
             </a:r>
             <a:br/>
             <a:br/>

</xml_diff>